<commit_message>
fix(ppt): polish slide layout, fix bullet indentation, clean architecture diagram, and update slide headings
</commit_message>
<xml_diff>
--- a/MD_Files/GramSaarthi_AI_Hackathon_Presentation.pptx
+++ b/MD_Files/GramSaarthi_AI_Hackathon_Presentation.pptx
@@ -12276,8 +12276,8 @@
         </p:nvSpPr>
         <p:spPr>
           <a:xfrm>
-            <a:off x="569214" y="1739062"/>
-            <a:ext cx="4293947" cy="2937686"/>
+            <a:off x="914400" y="1645920"/>
+            <a:ext cx="7315200" cy="2926080"/>
           </a:xfrm>
           <a:prstGeom prst="rect">
             <a:avLst/>
@@ -12323,11 +12323,11 @@
           <a:p>
             <a:pPr>
               <a:spcAft>
-                <a:spcPts val="800"/>
+                <a:spcPts val="1400"/>
               </a:spcAft>
             </a:pPr>
             <a:r>
-              <a:rPr sz="1300" b="1">
+              <a:rPr sz="1400" b="1">
                 <a:solidFill>
                   <a:srgbClr val="1E3A8A"/>
                 </a:solidFill>
@@ -12336,7 +12336,7 @@
               <a:t>Problem Statement Number : </a:t>
             </a:r>
             <a:r>
-              <a:rPr sz="1300" b="1">
+              <a:rPr sz="1400" b="1">
                 <a:solidFill>
                   <a:srgbClr val="059669"/>
                 </a:solidFill>
@@ -12348,11 +12348,11 @@
           <a:p>
             <a:pPr>
               <a:spcAft>
-                <a:spcPts val="800"/>
+                <a:spcPts val="1400"/>
               </a:spcAft>
             </a:pPr>
             <a:r>
-              <a:rPr sz="1300" b="1">
+              <a:rPr sz="1400" b="1">
                 <a:solidFill>
                   <a:srgbClr val="1E3A8A"/>
                 </a:solidFill>
@@ -12361,7 +12361,7 @@
               <a:t>Problem Statement Title : </a:t>
             </a:r>
             <a:r>
-              <a:rPr sz="1300" b="0">
+              <a:rPr sz="1400" b="0">
                 <a:solidFill>
                   <a:srgbClr val="1E293B"/>
                 </a:solidFill>
@@ -12373,11 +12373,11 @@
           <a:p>
             <a:pPr>
               <a:spcAft>
-                <a:spcPts val="800"/>
+                <a:spcPts val="1400"/>
               </a:spcAft>
             </a:pPr>
             <a:r>
-              <a:rPr sz="1300" b="1">
+              <a:rPr sz="1400" b="1">
                 <a:solidFill>
                   <a:srgbClr val="1E3A8A"/>
                 </a:solidFill>
@@ -12386,7 +12386,7 @@
               <a:t>Project Name : </a:t>
             </a:r>
             <a:r>
-              <a:rPr sz="1300" b="1">
+              <a:rPr sz="1400" b="1">
                 <a:solidFill>
                   <a:srgbClr val="059669"/>
                 </a:solidFill>
@@ -12398,11 +12398,11 @@
           <a:p>
             <a:pPr>
               <a:spcAft>
-                <a:spcPts val="800"/>
+                <a:spcPts val="1400"/>
               </a:spcAft>
             </a:pPr>
             <a:r>
-              <a:rPr sz="1300" b="1">
+              <a:rPr sz="1400" b="1">
                 <a:solidFill>
                   <a:srgbClr val="1E3A8A"/>
                 </a:solidFill>
@@ -12410,24 +12410,15 @@
               </a:rPr>
               <a:t>Team Name : </a:t>
             </a:r>
-            <a:r>
-              <a:rPr sz="1300" b="0">
-                <a:solidFill>
-                  <a:srgbClr val="1E293B"/>
-                </a:solidFill>
-                <a:latin typeface="Calibri"/>
-              </a:rPr>
-              <a:t>Rural Innovators / GramSaarthi Team</a:t>
-            </a:r>
           </a:p>
           <a:p>
             <a:pPr>
               <a:spcAft>
-                <a:spcPts val="800"/>
+                <a:spcPts val="1400"/>
               </a:spcAft>
             </a:pPr>
             <a:r>
-              <a:rPr sz="1300" b="1">
+              <a:rPr sz="1400" b="1">
                 <a:solidFill>
                   <a:srgbClr val="1E3A8A"/>
                 </a:solidFill>
@@ -12436,38 +12427,13 @@
               <a:t>Team Leader Name : </a:t>
             </a:r>
             <a:r>
-              <a:rPr sz="1300" b="1">
+              <a:rPr sz="1400" b="1">
                 <a:solidFill>
                   <a:srgbClr val="059669"/>
                 </a:solidFill>
                 <a:latin typeface="Calibri"/>
               </a:rPr>
               <a:t>Chirag Vasava</a:t>
-            </a:r>
-          </a:p>
-          <a:p>
-            <a:pPr>
-              <a:spcAft>
-                <a:spcPts val="800"/>
-              </a:spcAft>
-            </a:pPr>
-            <a:r>
-              <a:rPr sz="1300" b="1">
-                <a:solidFill>
-                  <a:srgbClr val="1E3A8A"/>
-                </a:solidFill>
-                <a:latin typeface="Calibri"/>
-              </a:rPr>
-              <a:t>GitHub Repository : </a:t>
-            </a:r>
-            <a:r>
-              <a:rPr sz="1300" b="0">
-                <a:solidFill>
-                  <a:srgbClr val="1E293B"/>
-                </a:solidFill>
-                <a:latin typeface="Calibri"/>
-              </a:rPr>
-              <a:t>https://github.com/ChiragVasava/gramsaarthi-ai.git</a:t>
             </a:r>
           </a:p>
         </p:txBody>
@@ -12677,17 +12643,15 @@
         </p:nvSpPr>
         <p:spPr>
           <a:xfrm>
-            <a:off x="728663" y="1829618"/>
-            <a:ext cx="4518041" cy="3003836"/>
+            <a:off x="640080" y="1280160"/>
+            <a:ext cx="3840480" cy="3566160"/>
           </a:xfrm>
           <a:prstGeom prst="rect">
             <a:avLst/>
           </a:prstGeom>
           <a:noFill/>
           <a:ln cap="flat" cmpd="sng" w="9525">
-            <a:solidFill>
-              <a:schemeClr val="dk1"/>
-            </a:solidFill>
+            <a:noFill/>
             <a:prstDash val="solid"/>
             <a:round/>
             <a:headEnd len="sm" w="sm" type="none"/>
@@ -12730,11 +12694,11 @@
           <a:p>
             <a:pPr>
               <a:spcAft>
-                <a:spcPts val="600"/>
+                <a:spcPts val="800"/>
               </a:spcAft>
             </a:pPr>
             <a:r>
-              <a:rPr sz="1300" b="1">
+              <a:rPr sz="1250" b="1">
                 <a:solidFill>
                   <a:srgbClr val="1E3A8A"/>
                 </a:solidFill>
@@ -12765,7 +12729,7 @@
                 </a:solidFill>
                 <a:latin typeface="Calibri"/>
               </a:rPr>
-              <a:t>70M+ rural micro-entrepreneurs face a 40%+ failure rate due to informal hearsay business planning and severely underutilized concessional credit schemes.</a:t>
+              <a:t>70M+ rural micro-entrepreneurs face a 40%+ failure rate due to informal hearsay business planning and underutilized concessional credit schemes.</a:t>
             </a:r>
           </a:p>
           <a:p>
@@ -12790,7 +12754,7 @@
                 </a:solidFill>
                 <a:latin typeface="Calibri"/>
               </a:rPr>
-              <a:t>An intelligent, trilingual rural advisory platform combining two decoupled engines:</a:t>
+              <a:t>An intelligent trilingual rural advisory platform combining two decoupled micro-engines:</a:t>
             </a:r>
           </a:p>
           <a:p>
@@ -12815,7 +12779,7 @@
                 </a:solidFill>
                 <a:latin typeface="Calibri"/>
               </a:rPr>
-              <a:t>Analyzes 5 km &amp; 10 km spatial catchment zones, demographic demand clustering, competitor density, seasonal threats, and live commodity pricing.</a:t>
+              <a:t>Analyzes 5 km &amp; 10 km spatial catchment zones, demographic demand, competitor density, seasonal threats, and commodity pricing.</a:t>
             </a:r>
           </a:p>
           <a:p>
@@ -12831,7 +12795,7 @@
                 </a:solidFill>
                 <a:latin typeface="Calibri"/>
               </a:rPr>
-              <a:t>•   2. Statutory Financial Structuring Engine: </a:t>
+              <a:t>•   2. Statutory Financial Structuring: </a:t>
             </a:r>
             <a:r>
               <a:rPr sz="950" b="0">
@@ -12840,7 +12804,7 @@
                 </a:solidFill>
                 <a:latin typeface="Calibri"/>
               </a:rPr>
-              <a:t>Implements audit-grade statutory debt sizing (10% Margin, 90% Debt), automatic scheme routing (Micro Finance vs. Term Loan), moratorium grace modeling, and quarterly amortization.</a:t>
+              <a:t>Deterministic debt sizing (10% Margin, 90% Debt), automatic scheme routing (Micro Finance vs. Term Loan), and quarterly amortization.</a:t>
             </a:r>
           </a:p>
           <a:p>
@@ -12896,26 +12860,7 @@
             <a:noAutofit/>
           </a:bodyPr>
           <a:lstStyle/>
-          <a:p>
-            <a:pPr indent="0" lvl="0" marL="0" rtl="0" algn="r">
-              <a:lnSpc>
-                <a:spcPct val="100000"/>
-              </a:lnSpc>
-              <a:spcBef>
-                <a:spcPts val="0"/>
-              </a:spcBef>
-              <a:spcAft>
-                <a:spcPts val="0"/>
-              </a:spcAft>
-              <a:buSzPts val="1000"/>
-              <a:buNone/>
-            </a:pPr>
-            <a:fld id="{00000000-1234-1234-1234-123412341234}" type="slidenum">
-              <a:rPr lang="en-GB"/>
-              <a:t>‹#›</a:t>
-            </a:fld>
-            <a:endParaRPr/>
-          </a:p>
+          <a:p/>
         </p:txBody>
       </p:sp>
       <p:sp>
@@ -12926,17 +12871,15 @@
         </p:nvSpPr>
         <p:spPr>
           <a:xfrm>
-            <a:off x="5533931" y="2178082"/>
-            <a:ext cx="3429001" cy="2457836"/>
+            <a:off x="4663440" y="1280160"/>
+            <a:ext cx="3840480" cy="3566160"/>
           </a:xfrm>
           <a:prstGeom prst="rect">
             <a:avLst/>
           </a:prstGeom>
           <a:noFill/>
           <a:ln cap="flat" cmpd="sng" w="9525">
-            <a:solidFill>
-              <a:schemeClr val="dk1"/>
-            </a:solidFill>
+            <a:noFill/>
             <a:prstDash val="solid"/>
             <a:round/>
             <a:headEnd len="sm" w="sm" type="none"/>
@@ -12979,11 +12922,11 @@
           <a:p>
             <a:pPr>
               <a:spcAft>
-                <a:spcPts val="600"/>
+                <a:spcPts val="800"/>
               </a:spcAft>
             </a:pPr>
             <a:r>
-              <a:rPr sz="1300" b="1">
+              <a:rPr sz="1250" b="1">
                 <a:solidFill>
                   <a:srgbClr val="1E3A8A"/>
                 </a:solidFill>
@@ -13005,7 +12948,7 @@
                 </a:solidFill>
                 <a:latin typeface="Calibri"/>
               </a:rPr>
-              <a:t>• Frontend &amp; App Router: </a:t>
+              <a:t>• Next.js 16 (React 19 App Router): </a:t>
             </a:r>
             <a:r>
               <a:rPr sz="950" b="0">
@@ -13014,7 +12957,7 @@
                 </a:solidFill>
                 <a:latin typeface="Calibri"/>
               </a:rPr>
-              <a:t>Next.js 16 (React 19) with lightning-fast static page generation &amp; server rendering.</a:t>
+              <a:t>Fast server-side rendering, modular client routing, and production build optimization.</a:t>
             </a:r>
           </a:p>
           <a:p>
@@ -13030,7 +12973,7 @@
                 </a:solidFill>
                 <a:latin typeface="Calibri"/>
               </a:rPr>
-              <a:t>• Language: </a:t>
+              <a:t>• TypeScript 5: </a:t>
             </a:r>
             <a:r>
               <a:rPr sz="950" b="0">
@@ -13039,7 +12982,7 @@
                 </a:solidFill>
                 <a:latin typeface="Calibri"/>
               </a:rPr>
-              <a:t>TypeScript 5 for strict mathematical type-safety across financial engines.</a:t>
+              <a:t>Strict mathematical type-safety across financial formulas, eliminating floating-point errors.</a:t>
             </a:r>
           </a:p>
           <a:p>
@@ -13055,7 +12998,7 @@
                 </a:solidFill>
                 <a:latin typeface="Calibri"/>
               </a:rPr>
-              <a:t>• Styling &amp; UI: </a:t>
+              <a:t>• Tailwind CSS 4: </a:t>
             </a:r>
             <a:r>
               <a:rPr sz="950" b="0">
@@ -13064,7 +13007,7 @@
                 </a:solidFill>
                 <a:latin typeface="Calibri"/>
               </a:rPr>
-              <a:t>Tailwind CSS 4 + Lucide Icons + print stylesheets for PDF dossiers.</a:t>
+              <a:t>Modern utility-first styling with custom print stylesheets for institutional PDF export.</a:t>
             </a:r>
           </a:p>
           <a:p>
@@ -13080,7 +13023,7 @@
                 </a:solidFill>
                 <a:latin typeface="Calibri"/>
               </a:rPr>
-              <a:t>• Database &amp; ORM: </a:t>
+              <a:t>• SQLite + Prisma ORM: </a:t>
             </a:r>
             <a:r>
               <a:rPr sz="950" b="0">
@@ -13089,7 +13032,7 @@
                 </a:solidFill>
                 <a:latin typeface="Calibri"/>
               </a:rPr>
-              <a:t>SQLite + Prisma ORM for zero-setup, self-contained evaluation.</a:t>
+              <a:t>Lightweight, portable relational persistence with zero external configuration required.</a:t>
             </a:r>
           </a:p>
           <a:p>
@@ -13105,7 +13048,7 @@
                 </a:solidFill>
                 <a:latin typeface="Calibri"/>
               </a:rPr>
-              <a:t>• Spatial Mapping: </a:t>
+              <a:t>• Leaflet.js Radar GIS: </a:t>
             </a:r>
             <a:r>
               <a:rPr sz="950" b="0">
@@ -13114,7 +13057,7 @@
                 </a:solidFill>
                 <a:latin typeface="Calibri"/>
               </a:rPr>
-              <a:t>Leaflet.js radial GIS radar (5 km &amp; 10 km catchment analytics).</a:t>
+              <a:t>Interactive 5 km &amp; 10 km concentric catchment radius visualization.</a:t>
             </a:r>
           </a:p>
           <a:p>
@@ -13130,7 +13073,7 @@
                 </a:solidFill>
                 <a:latin typeface="Calibri"/>
               </a:rPr>
-              <a:t>• AI &amp; Fallback Tier: </a:t>
+              <a:t>• Google Gemini 1.5 Flash + Fallback: </a:t>
             </a:r>
             <a:r>
               <a:rPr sz="950" b="0">
@@ -13139,7 +13082,7 @@
                 </a:solidFill>
                 <a:latin typeface="Calibri"/>
               </a:rPr>
-              <a:t>Google Gemini API + Deterministic Fallback Engine (100% demo uptime).</a:t>
+              <a:t>Contextual qualitative advisory paired with a 100% reliable offline fallback engine.</a:t>
             </a:r>
           </a:p>
           <a:p>
@@ -13155,7 +13098,7 @@
                 </a:solidFill>
                 <a:latin typeface="Calibri"/>
               </a:rPr>
-              <a:t>• Voice &amp; Inclusivity: </a:t>
+              <a:t>• Native Web Speech API: </a:t>
             </a:r>
             <a:r>
               <a:rPr sz="950" b="0">
@@ -13164,7 +13107,7 @@
                 </a:solidFill>
                 <a:latin typeface="Calibri"/>
               </a:rPr>
-              <a:t>Native Web Speech API supporting English, Hindi (HI), and Gujarati (GU).</a:t>
+              <a:t>Voice-first rural accessibility supporting English, Hindi (HI), and Gujarati (GU).</a:t>
             </a:r>
           </a:p>
         </p:txBody>
@@ -13436,8 +13379,8 @@
         </p:nvSpPr>
         <p:spPr>
           <a:xfrm>
-            <a:off x="714375" y="1711189"/>
-            <a:ext cx="3629025" cy="236936"/>
+            <a:off x="640080" y="1280160"/>
+            <a:ext cx="3840480" cy="365760"/>
           </a:xfrm>
           <a:prstGeom prst="rect">
             <a:avLst/>
@@ -13470,18 +13413,6 @@
               <a:buFont typeface="Arial"/>
               <a:buNone/>
             </a:pPr>
-            <a:r>
-              <a:rPr b="0" i="0" lang="en-GB" sz="1500" u="none" cap="none" strike="noStrike">
-                <a:solidFill>
-                  <a:schemeClr val="dk1"/>
-                </a:solidFill>
-                <a:latin typeface="Franklin Gothic"/>
-                <a:ea typeface="Franklin Gothic"/>
-                <a:cs typeface="Franklin Gothic"/>
-                <a:sym typeface="Franklin Gothic"/>
-              </a:rPr>
-              <a:t>Describe your Use Cases here</a:t>
-            </a:r>
             <a:endParaRPr b="0" i="0" sz="1100" u="none" cap="none" strike="noStrike">
               <a:solidFill>
                 <a:srgbClr val="000000"/>
@@ -13491,6 +13422,17 @@
               <a:cs typeface="Arial"/>
               <a:sym typeface="Arial"/>
             </a:endParaRPr>
+          </a:p>
+          <a:p>
+            <a:r>
+              <a:rPr sz="1250" b="1">
+                <a:solidFill>
+                  <a:srgbClr val="1E3A8A"/>
+                </a:solidFill>
+                <a:latin typeface="Calibri"/>
+              </a:rPr>
+              <a:t>Describe your Use Cases here</a:t>
+            </a:r>
           </a:p>
         </p:txBody>
       </p:sp>
@@ -13502,17 +13444,15 @@
         </p:nvSpPr>
         <p:spPr>
           <a:xfrm>
-            <a:off x="714374" y="1992677"/>
-            <a:ext cx="3629026" cy="2942226"/>
+            <a:off x="640080" y="1691640"/>
+            <a:ext cx="3840480" cy="3154680"/>
           </a:xfrm>
           <a:prstGeom prst="rect">
             <a:avLst/>
           </a:prstGeom>
           <a:noFill/>
           <a:ln cap="flat" cmpd="sng" w="9525">
-            <a:solidFill>
-              <a:schemeClr val="dk1"/>
-            </a:solidFill>
+            <a:noFill/>
             <a:prstDash val="solid"/>
             <a:round/>
             <a:headEnd len="sm" w="sm" type="none"/>
@@ -13561,11 +13501,11 @@
             <a:r>
               <a:rPr sz="1000" b="1">
                 <a:solidFill>
-                  <a:srgbClr val="1E3A8A"/>
+                  <a:srgbClr val="1E293B"/>
                 </a:solidFill>
                 <a:latin typeface="Calibri"/>
               </a:rPr>
-              <a:t>▶ Dairy / Livestock Unit Setup (e.g. 5-Cow Dairy):</a:t>
+              <a:t>▶ Dairy / Livestock Setup (e.g. 5-Cow Dairy):</a:t>
             </a:r>
           </a:p>
           <a:p>
@@ -13577,11 +13517,11 @@
             <a:r>
               <a:rPr sz="900" b="0">
                 <a:solidFill>
-                  <a:srgbClr val="1E293B"/>
+                  <a:srgbClr val="475569"/>
                 </a:solidFill>
                 <a:latin typeface="Calibri"/>
               </a:rPr>
-              <a:t>   • Founder enters ₹50,000 margin capital in 4-step wizard.</a:t>
+              <a:t>   • Founder inputs Rs 50,000 margin capital in 4-step wizard.</a:t>
             </a:r>
           </a:p>
           <a:p>
@@ -13593,11 +13533,11 @@
             <a:r>
               <a:rPr sz="900" b="0">
                 <a:solidFill>
-                  <a:srgbClr val="1E293B"/>
+                  <a:srgbClr val="475569"/>
                 </a:solidFill>
                 <a:latin typeface="Calibri"/>
               </a:rPr>
-              <a:t>   • System automatically sizes ₹5,00,000 project cost and ₹4,50,000 debt under Term Loan Scheme (8.0% p.a., 7 yrs, 6-mo moratorium).</a:t>
+              <a:t>   • System sizes Rs 5,00,000 project &amp; Rs 4,50,000 debt under Term Loan Scheme (8.0% p.a., 7 yrs, 6-mo moratorium).</a:t>
             </a:r>
           </a:p>
           <a:p>
@@ -13609,11 +13549,11 @@
             <a:r>
               <a:rPr sz="900" b="0">
                 <a:solidFill>
-                  <a:srgbClr val="1E293B"/>
+                  <a:srgbClr val="475569"/>
                 </a:solidFill>
                 <a:latin typeface="Calibri"/>
               </a:rPr>
-              <a:t>   • Spatial radar evaluates 5 km milk collection hubs, Amul chilling centers, and veterinary clinics.</a:t>
+              <a:t>   • Spatial radar evaluates 5 km milk collection hubs, chilling centers, and veterinary clinics.</a:t>
             </a:r>
           </a:p>
           <a:p>
@@ -13625,7 +13565,7 @@
             <a:r>
               <a:rPr sz="1000" b="1">
                 <a:solidFill>
-                  <a:srgbClr val="1E3A8A"/>
+                  <a:srgbClr val="1E293B"/>
                 </a:solidFill>
                 <a:latin typeface="Calibri"/>
               </a:rPr>
@@ -13641,11 +13581,11 @@
             <a:r>
               <a:rPr sz="900" b="0">
                 <a:solidFill>
-                  <a:srgbClr val="1E293B"/>
+                  <a:srgbClr val="475569"/>
                 </a:solidFill>
                 <a:latin typeface="Calibri"/>
               </a:rPr>
-              <a:t>   • Sizes ₹1,40,000 project with ₹14,000 margin under Micro Finance Scheme (6.5% p.a., 3 yrs, 3-mo moratorium).</a:t>
+              <a:t>   • Sizes Rs 1,40,000 project with Rs 14,000 margin under Micro Finance Scheme (6.5% p.a., 3 yrs, 3-mo moratorium).</a:t>
             </a:r>
           </a:p>
           <a:p>
@@ -13657,11 +13597,11 @@
             <a:r>
               <a:rPr sz="900" b="0">
                 <a:solidFill>
-                  <a:srgbClr val="1E293B"/>
+                  <a:srgbClr val="475569"/>
                 </a:solidFill>
                 <a:latin typeface="Calibri"/>
               </a:rPr>
-              <a:t>   • Calculates working capital buffer for seasonal inventory.</a:t>
+              <a:t>   • Calculates 3-month working capital buffer for seasonal inventory.</a:t>
             </a:r>
           </a:p>
           <a:p>
@@ -13673,11 +13613,11 @@
             <a:r>
               <a:rPr sz="1000" b="1">
                 <a:solidFill>
-                  <a:srgbClr val="1E3A8A"/>
+                  <a:srgbClr val="1E293B"/>
                 </a:solidFill>
                 <a:latin typeface="Calibri"/>
               </a:rPr>
-              <a:t>▶ Institutional Loan Application Preparation:</a:t>
+              <a:t>▶ Institutional Bank Appraisal Preparation:</a:t>
             </a:r>
           </a:p>
           <a:p>
@@ -13689,11 +13629,11 @@
             <a:r>
               <a:rPr sz="900" b="0">
                 <a:solidFill>
-                  <a:srgbClr val="1E293B"/>
+                  <a:srgbClr val="475569"/>
                 </a:solidFill>
                 <a:latin typeface="Calibri"/>
               </a:rPr>
-              <a:t>   • Generates audit-ready Feasibility Dossier with SWOT analysis and quarterly repayment schedule ready for Bank/SCA submission.</a:t>
+              <a:t>   • Generates audit-ready Feasibility Dossier with SWOT matrix and quarterly repayment schedule for Bank/SCA submission.</a:t>
             </a:r>
           </a:p>
           <a:p>
@@ -13705,7 +13645,7 @@
             <a:r>
               <a:rPr sz="1000" b="1">
                 <a:solidFill>
-                  <a:srgbClr val="1E3A8A"/>
+                  <a:srgbClr val="1E293B"/>
                 </a:solidFill>
                 <a:latin typeface="Calibri"/>
               </a:rPr>
@@ -13721,11 +13661,11 @@
             <a:r>
               <a:rPr sz="900" b="0">
                 <a:solidFill>
-                  <a:srgbClr val="1E293B"/>
+                  <a:srgbClr val="475569"/>
                 </a:solidFill>
                 <a:latin typeface="Calibri"/>
               </a:rPr>
-              <a:t>   • Rural founders ask questions via voice in Hindi or Gujarati and receive contextual guidance on loan repayments and threat mitigation.</a:t>
+              <a:t>   • Rural founders ask questions via voice in Hindi or Gujarati and receive contextual guidance on loan repayments and risk mitigation.</a:t>
             </a:r>
           </a:p>
         </p:txBody>
@@ -13738,8 +13678,8 @@
         </p:nvSpPr>
         <p:spPr>
           <a:xfrm>
-            <a:off x="4591487" y="1734298"/>
-            <a:ext cx="4409210" cy="190717"/>
+            <a:off x="4663440" y="1280160"/>
+            <a:ext cx="3840480" cy="365760"/>
           </a:xfrm>
           <a:prstGeom prst="rect">
             <a:avLst/>
@@ -13772,18 +13712,6 @@
               <a:buFont typeface="Arial"/>
               <a:buNone/>
             </a:pPr>
-            <a:r>
-              <a:rPr b="0" i="0" lang="en-GB" sz="1500" u="none" cap="none" strike="noStrike">
-                <a:solidFill>
-                  <a:schemeClr val="dk1"/>
-                </a:solidFill>
-                <a:latin typeface="Franklin Gothic"/>
-                <a:ea typeface="Franklin Gothic"/>
-                <a:cs typeface="Franklin Gothic"/>
-                <a:sym typeface="Franklin Gothic"/>
-              </a:rPr>
-              <a:t>Describe your Dependencies</a:t>
-            </a:r>
             <a:endParaRPr b="0" i="0" sz="1500" u="none" cap="none" strike="noStrike">
               <a:solidFill>
                 <a:schemeClr val="dk1"/>
@@ -13793,6 +13721,17 @@
               <a:cs typeface="Franklin Gothic"/>
               <a:sym typeface="Franklin Gothic"/>
             </a:endParaRPr>
+          </a:p>
+          <a:p>
+            <a:r>
+              <a:rPr sz="1250" b="1">
+                <a:solidFill>
+                  <a:srgbClr val="1E3A8A"/>
+                </a:solidFill>
+                <a:latin typeface="Calibri"/>
+              </a:rPr>
+              <a:t>Describe your Dependencies</a:t>
+            </a:r>
           </a:p>
         </p:txBody>
       </p:sp>
@@ -13804,17 +13743,15 @@
         </p:nvSpPr>
         <p:spPr>
           <a:xfrm>
-            <a:off x="4686299" y="1992677"/>
-            <a:ext cx="3816146" cy="2942226"/>
+            <a:off x="4663440" y="1691640"/>
+            <a:ext cx="3840480" cy="3154680"/>
           </a:xfrm>
           <a:prstGeom prst="rect">
             <a:avLst/>
           </a:prstGeom>
           <a:noFill/>
           <a:ln cap="flat" cmpd="sng" w="9525">
-            <a:solidFill>
-              <a:schemeClr val="dk1"/>
-            </a:solidFill>
+            <a:noFill/>
             <a:prstDash val="solid"/>
             <a:round/>
             <a:headEnd len="sm" w="sm" type="none"/>
@@ -13863,11 +13800,11 @@
             <a:r>
               <a:rPr sz="1000" b="1">
                 <a:solidFill>
-                  <a:srgbClr val="1E3A8A"/>
+                  <a:srgbClr val="1E293B"/>
                 </a:solidFill>
                 <a:latin typeface="Calibri"/>
               </a:rPr>
-              <a:t>▶ Core Software Dependencies:</a:t>
+              <a:t>▶ Core Software Frameworks:</a:t>
             </a:r>
           </a:p>
           <a:p>
@@ -13879,7 +13816,7 @@
             <a:r>
               <a:rPr sz="900" b="0">
                 <a:solidFill>
-                  <a:srgbClr val="1E293B"/>
+                  <a:srgbClr val="475569"/>
                 </a:solidFill>
                 <a:latin typeface="Calibri"/>
               </a:rPr>
@@ -13895,7 +13832,7 @@
             <a:r>
               <a:rPr sz="900" b="0">
                 <a:solidFill>
-                  <a:srgbClr val="1E293B"/>
+                  <a:srgbClr val="475569"/>
                 </a:solidFill>
                 <a:latin typeface="Calibri"/>
               </a:rPr>
@@ -13911,7 +13848,7 @@
             <a:r>
               <a:rPr sz="900" b="0">
                 <a:solidFill>
-                  <a:srgbClr val="1E293B"/>
+                  <a:srgbClr val="475569"/>
                 </a:solidFill>
                 <a:latin typeface="Calibri"/>
               </a:rPr>
@@ -13927,7 +13864,7 @@
             <a:r>
               <a:rPr sz="900" b="0">
                 <a:solidFill>
-                  <a:srgbClr val="1E293B"/>
+                  <a:srgbClr val="475569"/>
                 </a:solidFill>
                 <a:latin typeface="Calibri"/>
               </a:rPr>
@@ -13943,7 +13880,7 @@
             <a:r>
               <a:rPr sz="1000" b="1">
                 <a:solidFill>
-                  <a:srgbClr val="1E3A8A"/>
+                  <a:srgbClr val="1E293B"/>
                 </a:solidFill>
                 <a:latin typeface="Calibri"/>
               </a:rPr>
@@ -13959,7 +13896,7 @@
             <a:r>
               <a:rPr sz="900" b="0">
                 <a:solidFill>
-                  <a:srgbClr val="1E293B"/>
+                  <a:srgbClr val="475569"/>
                 </a:solidFill>
                 <a:latin typeface="Calibri"/>
               </a:rPr>
@@ -13975,7 +13912,7 @@
             <a:r>
               <a:rPr sz="900" b="0">
                 <a:solidFill>
-                  <a:srgbClr val="1E293B"/>
+                  <a:srgbClr val="475569"/>
                 </a:solidFill>
                 <a:latin typeface="Calibri"/>
               </a:rPr>
@@ -13991,7 +13928,7 @@
             <a:r>
               <a:rPr sz="900" b="0">
                 <a:solidFill>
-                  <a:srgbClr val="1E293B"/>
+                  <a:srgbClr val="475569"/>
                 </a:solidFill>
                 <a:latin typeface="Calibri"/>
               </a:rPr>
@@ -14007,11 +13944,11 @@
             <a:r>
               <a:rPr sz="1000" b="1">
                 <a:solidFill>
-                  <a:srgbClr val="1E3A8A"/>
+                  <a:srgbClr val="1E293B"/>
                 </a:solidFill>
                 <a:latin typeface="Calibri"/>
               </a:rPr>
-              <a:t>▶ Hardware &amp; Deployment Prerequisites:</a:t>
+              <a:t>▶ Hardware &amp; Deployment Architecture:</a:t>
             </a:r>
           </a:p>
           <a:p>
@@ -14023,11 +13960,11 @@
             <a:r>
               <a:rPr sz="900" b="0">
                 <a:solidFill>
-                  <a:srgbClr val="1E293B"/>
+                  <a:srgbClr val="475569"/>
                 </a:solidFill>
                 <a:latin typeface="Calibri"/>
               </a:rPr>
-              <a:t>   • Runs on any standard PC, laptop, or modern mobile browser</a:t>
+              <a:t>   • Runs locally on any standard PC, laptop, or mobile browser</a:t>
             </a:r>
           </a:p>
           <a:p>
@@ -14039,11 +13976,11 @@
             <a:r>
               <a:rPr sz="900" b="0">
                 <a:solidFill>
-                  <a:srgbClr val="1E293B"/>
+                  <a:srgbClr val="475569"/>
                 </a:solidFill>
                 <a:latin typeface="Calibri"/>
               </a:rPr>
-              <a:t>   • Zero cloud infrastructure required: 100% portable local SQLite database with demo credentials pre-seeded</a:t>
+              <a:t>   • Zero cloud setup: 100% portable SQLite database with pre-configured demo evaluator account</a:t>
             </a:r>
           </a:p>
           <a:p>
@@ -14055,7 +13992,7 @@
             <a:r>
               <a:rPr sz="900" b="0">
                 <a:solidFill>
-                  <a:srgbClr val="1E293B"/>
+                  <a:srgbClr val="475569"/>
                 </a:solidFill>
                 <a:latin typeface="Calibri"/>
               </a:rPr>
@@ -14323,8 +14260,8 @@
         </p:nvSpPr>
         <p:spPr>
           <a:xfrm>
-            <a:off x="629841" y="1260872"/>
-            <a:ext cx="3868200" cy="618000"/>
+            <a:off x="640080" y="1280160"/>
+            <a:ext cx="3840480" cy="365760"/>
           </a:xfrm>
           <a:prstGeom prst="rect">
             <a:avLst/>
@@ -14353,18 +14290,6 @@
               <a:buSzPts val="1800"/>
               <a:buNone/>
             </a:pPr>
-            <a:r>
-              <a:rPr b="0" lang="en-GB" sz="1500">
-                <a:solidFill>
-                  <a:schemeClr val="dk1"/>
-                </a:solidFill>
-                <a:latin typeface="Franklin Gothic"/>
-                <a:ea typeface="Franklin Gothic"/>
-                <a:cs typeface="Franklin Gothic"/>
-                <a:sym typeface="Franklin Gothic"/>
-              </a:rPr>
-              <a:t>Uniqueness of your Idea</a:t>
-            </a:r>
             <a:endParaRPr b="0" sz="1500">
               <a:solidFill>
                 <a:schemeClr val="dk1"/>
@@ -14375,238 +14300,16 @@
               <a:sym typeface="Franklin Gothic"/>
             </a:endParaRPr>
           </a:p>
-        </p:txBody>
-      </p:sp>
-      <p:sp>
-        <p:nvSpPr>
-          <p:cNvPr id="107" name="Google Shape;107;p4"/>
-          <p:cNvSpPr txBox="1"/>
-          <p:nvPr>
-            <p:ph idx="2" type="body"/>
-          </p:nvPr>
-        </p:nvSpPr>
-        <p:spPr>
-          <a:xfrm>
-            <a:off x="629841" y="1878806"/>
-            <a:ext cx="3868200" cy="2763300"/>
-          </a:xfrm>
-          <a:prstGeom prst="rect">
-            <a:avLst/>
-          </a:prstGeom>
-          <a:noFill/>
-          <a:ln>
-            <a:noFill/>
-          </a:ln>
-        </p:spPr>
-        <p:txBody>
-          <a:bodyPr anchorCtr="0" anchor="t" bIns="34275" lIns="68575" spcFirstLastPara="1" rIns="68575" wrap="square" tIns="34275">
-            <a:normAutofit/>
-          </a:bodyPr>
-          <a:lstStyle/>
           <a:p>
-            <a:pPr indent="0" lvl="0" marL="0" rtl="0" algn="l">
-              <a:lnSpc>
-                <a:spcPct val="90000"/>
-              </a:lnSpc>
-              <a:spcBef>
-                <a:spcPts val="800"/>
-              </a:spcBef>
-              <a:spcAft>
-                <a:spcPts val="0"/>
-              </a:spcAft>
-              <a:buSzPts val="1400"/>
-              <a:buNone/>
-            </a:pPr>
-            <a:endParaRPr/>
-          </a:p>
-          <a:p>
-            <a:pPr>
-              <a:spcAft>
-                <a:spcPts val="400"/>
-              </a:spcAft>
-            </a:pPr>
             <a:r>
-              <a:rPr sz="950" b="1">
+              <a:rPr sz="1250" b="1">
                 <a:solidFill>
                   <a:srgbClr val="1E3A8A"/>
                 </a:solidFill>
                 <a:latin typeface="Calibri"/>
               </a:rPr>
-              <a:t>★ Decoupled Deterministic Financial Engine: </a:t>
+              <a:t>Uniqueness of your Idea</a:t>
             </a:r>
-            <a:r>
-              <a:rPr sz="950" b="0">
-                <a:solidFill>
-                  <a:srgbClr val="1E293B"/>
-                </a:solidFill>
-                <a:latin typeface="Calibri"/>
-              </a:rPr>
-              <a:t>Unlike naive LLM wrappers that hallucinate loan math, debt sizing, interest rates, and amortizations are computed by an exact deterministic TypeScript algorithm conforming to statutory guidelines.</a:t>
-            </a:r>
-          </a:p>
-          <a:p>
-            <a:pPr>
-              <a:spcAft>
-                <a:spcPts val="400"/>
-              </a:spcAft>
-            </a:pPr>
-            <a:r>
-              <a:rPr sz="950" b="1">
-                <a:solidFill>
-                  <a:srgbClr val="1E3A8A"/>
-                </a:solidFill>
-                <a:latin typeface="Calibri"/>
-              </a:rPr>
-              <a:t>★ Automated Statutory Scheme Routing: </a:t>
-            </a:r>
-            <a:r>
-              <a:rPr sz="950" b="0">
-                <a:solidFill>
-                  <a:srgbClr val="1E293B"/>
-                </a:solidFill>
-                <a:latin typeface="Calibri"/>
-              </a:rPr>
-              <a:t>Intelligently routes projects &lt;= ₹1.40L to Micro Finance (6.5%, 3-yr, 3-mo moratorium) and &gt; ₹1.40L to Term Loan (8.0%, 7-yr, 6-mo moratorium) without manual loan officer intervention.</a:t>
-            </a:r>
-          </a:p>
-          <a:p>
-            <a:pPr>
-              <a:spcAft>
-                <a:spcPts val="400"/>
-              </a:spcAft>
-            </a:pPr>
-            <a:r>
-              <a:rPr sz="950" b="1">
-                <a:solidFill>
-                  <a:srgbClr val="1E3A8A"/>
-                </a:solidFill>
-                <a:latin typeface="Calibri"/>
-              </a:rPr>
-              <a:t>★ Hyper-Local Concentric Catchment (5 &amp; 10 km): </a:t>
-            </a:r>
-            <a:r>
-              <a:rPr sz="950" b="0">
-                <a:solidFill>
-                  <a:srgbClr val="1E293B"/>
-                </a:solidFill>
-                <a:latin typeface="Calibri"/>
-              </a:rPr>
-              <a:t>Provides granular spatial demographic density, competitor proximity, and mandi linkage rather than generic national advice.</a:t>
-            </a:r>
-          </a:p>
-          <a:p>
-            <a:pPr>
-              <a:spcAft>
-                <a:spcPts val="400"/>
-              </a:spcAft>
-            </a:pPr>
-            <a:r>
-              <a:rPr sz="950" b="1">
-                <a:solidFill>
-                  <a:srgbClr val="1E3A8A"/>
-                </a:solidFill>
-                <a:latin typeface="Calibri"/>
-              </a:rPr>
-              <a:t>★ Trilingual Rural Accessibility: </a:t>
-            </a:r>
-            <a:r>
-              <a:rPr sz="950" b="0">
-                <a:solidFill>
-                  <a:srgbClr val="1E293B"/>
-                </a:solidFill>
-                <a:latin typeface="Calibri"/>
-              </a:rPr>
-              <a:t>Voice input and localized UI in English, Hindi, and Gujarati overcomes rural literacy barriers.</a:t>
-            </a:r>
-          </a:p>
-          <a:p>
-            <a:pPr>
-              <a:spcAft>
-                <a:spcPts val="400"/>
-              </a:spcAft>
-            </a:pPr>
-            <a:r>
-              <a:rPr sz="950" b="1">
-                <a:solidFill>
-                  <a:srgbClr val="1E3A8A"/>
-                </a:solidFill>
-                <a:latin typeface="Calibri"/>
-              </a:rPr>
-              <a:t>★ Production-Ready &amp; Fully Functional: </a:t>
-            </a:r>
-            <a:r>
-              <a:rPr sz="950" b="0">
-                <a:solidFill>
-                  <a:srgbClr val="1E293B"/>
-                </a:solidFill>
-                <a:latin typeface="Calibri"/>
-              </a:rPr>
-              <a:t>Not just mockups—a fully implemented web app with 10 working routes, SQLite database, and instant PDF dossier generation.</a:t>
-            </a:r>
-          </a:p>
-        </p:txBody>
-      </p:sp>
-      <p:sp>
-        <p:nvSpPr>
-          <p:cNvPr id="108" name="Google Shape;108;p4"/>
-          <p:cNvSpPr txBox="1"/>
-          <p:nvPr>
-            <p:ph idx="3" type="body"/>
-          </p:nvPr>
-        </p:nvSpPr>
-        <p:spPr>
-          <a:xfrm>
-            <a:off x="4629150" y="1260872"/>
-            <a:ext cx="3887400" cy="618000"/>
-          </a:xfrm>
-          <a:prstGeom prst="rect">
-            <a:avLst/>
-          </a:prstGeom>
-          <a:noFill/>
-          <a:ln>
-            <a:noFill/>
-          </a:ln>
-        </p:spPr>
-        <p:txBody>
-          <a:bodyPr anchorCtr="0" anchor="b" bIns="34275" lIns="68575" spcFirstLastPara="1" rIns="68575" wrap="square" tIns="34275">
-            <a:normAutofit/>
-          </a:bodyPr>
-          <a:lstStyle/>
-          <a:p>
-            <a:pPr indent="0" lvl="0" marL="0" rtl="0" algn="l">
-              <a:lnSpc>
-                <a:spcPct val="90000"/>
-              </a:lnSpc>
-              <a:spcBef>
-                <a:spcPts val="800"/>
-              </a:spcBef>
-              <a:spcAft>
-                <a:spcPts val="0"/>
-              </a:spcAft>
-              <a:buSzPts val="1800"/>
-              <a:buNone/>
-            </a:pPr>
-            <a:r>
-              <a:rPr lang="en-GB" sz="1500">
-                <a:solidFill>
-                  <a:schemeClr val="dk1"/>
-                </a:solidFill>
-                <a:latin typeface="Franklin Gothic"/>
-                <a:ea typeface="Franklin Gothic"/>
-                <a:cs typeface="Franklin Gothic"/>
-                <a:sym typeface="Franklin Gothic"/>
-              </a:rPr>
-              <a:t>Future Scope and Impact</a:t>
-            </a:r>
-            <a:endParaRPr sz="1500">
-              <a:solidFill>
-                <a:schemeClr val="dk1"/>
-              </a:solidFill>
-              <a:latin typeface="Franklin Gothic"/>
-              <a:ea typeface="Franklin Gothic"/>
-              <a:cs typeface="Franklin Gothic"/>
-              <a:sym typeface="Franklin Gothic"/>
-            </a:endParaRPr>
           </a:p>
         </p:txBody>
       </p:sp>
@@ -14650,151 +14353,10 @@
               <a:buSzPts val="1400"/>
               <a:buNone/>
             </a:pPr>
+            <a:r>
+              <a:t/>
+            </a:r>
             <a:endParaRPr/>
-          </a:p>
-          <a:p>
-            <a:pPr>
-              <a:spcAft>
-                <a:spcPts val="200"/>
-              </a:spcAft>
-            </a:pPr>
-            <a:r>
-              <a:rPr sz="1000" b="1">
-                <a:solidFill>
-                  <a:srgbClr val="1E3A8A"/>
-                </a:solidFill>
-                <a:latin typeface="Calibri"/>
-              </a:rPr>
-              <a:t>▶ Measurable Socio-Economic Impact:</a:t>
-            </a:r>
-          </a:p>
-          <a:p>
-            <a:pPr>
-              <a:spcAft>
-                <a:spcPts val="200"/>
-              </a:spcAft>
-            </a:pPr>
-            <a:r>
-              <a:rPr sz="900" b="0">
-                <a:solidFill>
-                  <a:srgbClr val="1E293B"/>
-                </a:solidFill>
-                <a:latin typeface="Calibri"/>
-              </a:rPr>
-              <a:t>   • Reduces 40%+ early enterprise mortality by replacing hearsay with data-driven demand validation.</a:t>
-            </a:r>
-          </a:p>
-          <a:p>
-            <a:pPr>
-              <a:spcAft>
-                <a:spcPts val="200"/>
-              </a:spcAft>
-            </a:pPr>
-            <a:r>
-              <a:rPr sz="900" b="0">
-                <a:solidFill>
-                  <a:srgbClr val="1E293B"/>
-                </a:solidFill>
-                <a:latin typeface="Calibri"/>
-              </a:rPr>
-              <a:t>   • Unlocks statutory concessional debt for marginalized rural founders, replacing predatory moneylenders (36%+ p.a.) with 6.5%–8% subsidized credit.</a:t>
-            </a:r>
-          </a:p>
-          <a:p>
-            <a:pPr>
-              <a:spcAft>
-                <a:spcPts val="200"/>
-              </a:spcAft>
-            </a:pPr>
-            <a:r>
-              <a:rPr sz="900" b="0">
-                <a:solidFill>
-                  <a:srgbClr val="1E293B"/>
-                </a:solidFill>
-                <a:latin typeface="Calibri"/>
-              </a:rPr>
-              <a:t>   • Cuts bank dossier appraisal preparation time from 3 weeks to under 3 minutes.</a:t>
-            </a:r>
-          </a:p>
-          <a:p>
-            <a:pPr>
-              <a:spcAft>
-                <a:spcPts val="200"/>
-              </a:spcAft>
-            </a:pPr>
-            <a:r>
-              <a:rPr sz="1000" b="1">
-                <a:solidFill>
-                  <a:srgbClr val="1E3A8A"/>
-                </a:solidFill>
-                <a:latin typeface="Calibri"/>
-              </a:rPr>
-              <a:t>▶ Future Engineering Scope &amp; Roadmap:</a:t>
-            </a:r>
-          </a:p>
-          <a:p>
-            <a:pPr>
-              <a:spcAft>
-                <a:spcPts val="200"/>
-              </a:spcAft>
-            </a:pPr>
-            <a:r>
-              <a:rPr sz="900" b="0">
-                <a:solidFill>
-                  <a:srgbClr val="1E293B"/>
-                </a:solidFill>
-                <a:latin typeface="Calibri"/>
-              </a:rPr>
-              <a:t>   • SCA &amp; JanSamarth Portal API: Direct automated digital loan application dispatch to State Channelizing Agencies &amp; national banks.</a:t>
-            </a:r>
-          </a:p>
-          <a:p>
-            <a:pPr>
-              <a:spcAft>
-                <a:spcPts val="200"/>
-              </a:spcAft>
-            </a:pPr>
-            <a:r>
-              <a:rPr sz="900" b="0">
-                <a:solidFill>
-                  <a:srgbClr val="1E293B"/>
-                </a:solidFill>
-                <a:latin typeface="Calibri"/>
-              </a:rPr>
-              <a:t>   • Live Mandi &amp; APMC Feeds: Real-time price tracking via e-NAM APIs for hyper-local commodity arbitrage guidance.</a:t>
-            </a:r>
-          </a:p>
-          <a:p>
-            <a:pPr>
-              <a:spcAft>
-                <a:spcPts val="200"/>
-              </a:spcAft>
-            </a:pPr>
-            <a:r>
-              <a:rPr sz="900" b="0">
-                <a:solidFill>
-                  <a:srgbClr val="1E293B"/>
-                </a:solidFill>
-                <a:latin typeface="Calibri"/>
-              </a:rPr>
-              <a:t>   • Offline PWA &amp; Edge AI: Local on-device LLM execution (Gemma 2B / WebLLM) for zero-connectivity deep rural villages.</a:t>
-            </a:r>
-          </a:p>
-          <a:p>
-            <a:pPr>
-              <a:spcAft>
-                <a:spcPts val="200"/>
-              </a:spcAft>
-            </a:pPr>
-            <a:r>
-              <a:rPr sz="900" b="0">
-                <a:solidFill>
-                  <a:srgbClr val="1E293B"/>
-                </a:solidFill>
-                <a:latin typeface="Calibri"/>
-              </a:rPr>
-              <a:t>   • SHG &amp; Cooperative Multi-Tenant Mode: Sizing pooled capital for Self-Help Groups and Village Milk Societies.</a:t>
-            </a:r>
           </a:p>
         </p:txBody>
       </p:sp>
@@ -14852,6 +14414,323 @@
           </a:ln>
         </p:spPr>
       </p:pic>
+      <p:sp>
+        <p:nvSpPr>
+          <p:cNvPr id="112" name="TextBox 111"/>
+          <p:cNvSpPr txBox="1"/>
+          <p:nvPr/>
+        </p:nvSpPr>
+        <p:spPr>
+          <a:xfrm>
+            <a:off x="640080" y="1691640"/>
+            <a:ext cx="3840480" cy="3154680"/>
+          </a:xfrm>
+          <a:prstGeom prst="rect">
+            <a:avLst/>
+          </a:prstGeom>
+          <a:noFill/>
+        </p:spPr>
+        <p:txBody>
+          <a:bodyPr wrap="square">
+            <a:spAutoFit/>
+          </a:bodyPr>
+          <a:lstStyle/>
+          <a:p/>
+          <a:p>
+            <a:pPr>
+              <a:spcAft>
+                <a:spcPts val="400"/>
+              </a:spcAft>
+            </a:pPr>
+            <a:r>
+              <a:rPr sz="950" b="1">
+                <a:solidFill>
+                  <a:srgbClr val="1E293B"/>
+                </a:solidFill>
+                <a:latin typeface="Calibri"/>
+              </a:rPr>
+              <a:t>• Decoupled Deterministic Financial Engine: </a:t>
+            </a:r>
+            <a:r>
+              <a:rPr sz="950" b="0">
+                <a:solidFill>
+                  <a:srgbClr val="475569"/>
+                </a:solidFill>
+                <a:latin typeface="Calibri"/>
+              </a:rPr>
+              <a:t>Unlike naive LLM wrappers that hallucinate loan math, debt sizing, interest rates, and amortizations are computed by an exact deterministic TypeScript algorithm conforming to statutory guidelines.</a:t>
+            </a:r>
+          </a:p>
+          <a:p>
+            <a:pPr>
+              <a:spcAft>
+                <a:spcPts val="400"/>
+              </a:spcAft>
+            </a:pPr>
+            <a:r>
+              <a:rPr sz="950" b="1">
+                <a:solidFill>
+                  <a:srgbClr val="1E293B"/>
+                </a:solidFill>
+                <a:latin typeface="Calibri"/>
+              </a:rPr>
+              <a:t>• Automated Statutory Scheme Routing: </a:t>
+            </a:r>
+            <a:r>
+              <a:rPr sz="950" b="0">
+                <a:solidFill>
+                  <a:srgbClr val="475569"/>
+                </a:solidFill>
+                <a:latin typeface="Calibri"/>
+              </a:rPr>
+              <a:t>Intelligently routes projects &lt;= Rs 1.40L to Micro Finance (6.5%, 3-yr, 3-mo moratorium) and &gt; Rs 1.40L to Term Loan (8.0%, 7-yr, 6-mo moratorium) without manual loan officer intervention.</a:t>
+            </a:r>
+          </a:p>
+          <a:p>
+            <a:pPr>
+              <a:spcAft>
+                <a:spcPts val="400"/>
+              </a:spcAft>
+            </a:pPr>
+            <a:r>
+              <a:rPr sz="950" b="1">
+                <a:solidFill>
+                  <a:srgbClr val="1E293B"/>
+                </a:solidFill>
+                <a:latin typeface="Calibri"/>
+              </a:rPr>
+              <a:t>• Hyper-Local Concentric Catchment (5 &amp; 10 km): </a:t>
+            </a:r>
+            <a:r>
+              <a:rPr sz="950" b="0">
+                <a:solidFill>
+                  <a:srgbClr val="475569"/>
+                </a:solidFill>
+                <a:latin typeface="Calibri"/>
+              </a:rPr>
+              <a:t>Provides granular spatial demographic density, competitor proximity, and mandi linkage rather than generic national advice.</a:t>
+            </a:r>
+          </a:p>
+          <a:p>
+            <a:pPr>
+              <a:spcAft>
+                <a:spcPts val="400"/>
+              </a:spcAft>
+            </a:pPr>
+            <a:r>
+              <a:rPr sz="950" b="1">
+                <a:solidFill>
+                  <a:srgbClr val="1E293B"/>
+                </a:solidFill>
+                <a:latin typeface="Calibri"/>
+              </a:rPr>
+              <a:t>• Trilingual Rural Accessibility: </a:t>
+            </a:r>
+            <a:r>
+              <a:rPr sz="950" b="0">
+                <a:solidFill>
+                  <a:srgbClr val="475569"/>
+                </a:solidFill>
+                <a:latin typeface="Calibri"/>
+              </a:rPr>
+              <a:t>Voice input and localized UI in English, Hindi, and Gujarati overcomes rural literacy barriers.</a:t>
+            </a:r>
+          </a:p>
+          <a:p>
+            <a:pPr>
+              <a:spcAft>
+                <a:spcPts val="400"/>
+              </a:spcAft>
+            </a:pPr>
+            <a:r>
+              <a:rPr sz="950" b="1">
+                <a:solidFill>
+                  <a:srgbClr val="1E293B"/>
+                </a:solidFill>
+                <a:latin typeface="Calibri"/>
+              </a:rPr>
+              <a:t>• Production-Ready &amp; Fully Functional: </a:t>
+            </a:r>
+            <a:r>
+              <a:rPr sz="950" b="0">
+                <a:solidFill>
+                  <a:srgbClr val="475569"/>
+                </a:solidFill>
+                <a:latin typeface="Calibri"/>
+              </a:rPr>
+              <a:t>Not just mockups—a fully working web app with 10 active routes, SQLite database, and instant PDF dossier generation.</a:t>
+            </a:r>
+          </a:p>
+        </p:txBody>
+      </p:sp>
+      <p:sp>
+        <p:nvSpPr>
+          <p:cNvPr id="113" name="TextBox 112"/>
+          <p:cNvSpPr txBox="1"/>
+          <p:nvPr/>
+        </p:nvSpPr>
+        <p:spPr>
+          <a:xfrm>
+            <a:off x="4663440" y="1691640"/>
+            <a:ext cx="3840480" cy="3154680"/>
+          </a:xfrm>
+          <a:prstGeom prst="rect">
+            <a:avLst/>
+          </a:prstGeom>
+          <a:noFill/>
+        </p:spPr>
+        <p:txBody>
+          <a:bodyPr wrap="square">
+            <a:spAutoFit/>
+          </a:bodyPr>
+          <a:lstStyle/>
+          <a:p/>
+          <a:p>
+            <a:pPr>
+              <a:spcAft>
+                <a:spcPts val="200"/>
+              </a:spcAft>
+            </a:pPr>
+            <a:r>
+              <a:rPr sz="1000" b="1">
+                <a:solidFill>
+                  <a:srgbClr val="1E293B"/>
+                </a:solidFill>
+                <a:latin typeface="Calibri"/>
+              </a:rPr>
+              <a:t>▶ Measurable Socio-Economic Impact:</a:t>
+            </a:r>
+          </a:p>
+          <a:p>
+            <a:pPr>
+              <a:spcAft>
+                <a:spcPts val="200"/>
+              </a:spcAft>
+            </a:pPr>
+            <a:r>
+              <a:rPr sz="900" b="0">
+                <a:solidFill>
+                  <a:srgbClr val="475569"/>
+                </a:solidFill>
+                <a:latin typeface="Calibri"/>
+              </a:rPr>
+              <a:t>   • Reduces 40%+ early enterprise mortality by replacing hearsay with data-driven demand validation.</a:t>
+            </a:r>
+          </a:p>
+          <a:p>
+            <a:pPr>
+              <a:spcAft>
+                <a:spcPts val="200"/>
+              </a:spcAft>
+            </a:pPr>
+            <a:r>
+              <a:rPr sz="900" b="0">
+                <a:solidFill>
+                  <a:srgbClr val="475569"/>
+                </a:solidFill>
+                <a:latin typeface="Calibri"/>
+              </a:rPr>
+              <a:t>   • Unlocks statutory concessional debt for marginalized rural founders, replacing predatory moneylenders (36%+ p.a.) with 6.5%–8% subsidized credit.</a:t>
+            </a:r>
+          </a:p>
+          <a:p>
+            <a:pPr>
+              <a:spcAft>
+                <a:spcPts val="200"/>
+              </a:spcAft>
+            </a:pPr>
+            <a:r>
+              <a:rPr sz="900" b="0">
+                <a:solidFill>
+                  <a:srgbClr val="475569"/>
+                </a:solidFill>
+                <a:latin typeface="Calibri"/>
+              </a:rPr>
+              <a:t>   • Cuts bank appraisal preparation time from 3 weeks to under 3 minutes.</a:t>
+            </a:r>
+          </a:p>
+          <a:p>
+            <a:pPr>
+              <a:spcAft>
+                <a:spcPts val="200"/>
+              </a:spcAft>
+            </a:pPr>
+            <a:r>
+              <a:rPr sz="1000" b="1">
+                <a:solidFill>
+                  <a:srgbClr val="1E293B"/>
+                </a:solidFill>
+                <a:latin typeface="Calibri"/>
+              </a:rPr>
+              <a:t>▶ Future Engineering Scope &amp; Roadmap:</a:t>
+            </a:r>
+          </a:p>
+          <a:p>
+            <a:pPr>
+              <a:spcAft>
+                <a:spcPts val="200"/>
+              </a:spcAft>
+            </a:pPr>
+            <a:r>
+              <a:rPr sz="900" b="0">
+                <a:solidFill>
+                  <a:srgbClr val="475569"/>
+                </a:solidFill>
+                <a:latin typeface="Calibri"/>
+              </a:rPr>
+              <a:t>   • SCA &amp; JanSamarth Portal API: Direct automated loan application dispatch to State Channelizing Agencies &amp; national banks.</a:t>
+            </a:r>
+          </a:p>
+          <a:p>
+            <a:pPr>
+              <a:spcAft>
+                <a:spcPts val="200"/>
+              </a:spcAft>
+            </a:pPr>
+            <a:r>
+              <a:rPr sz="900" b="0">
+                <a:solidFill>
+                  <a:srgbClr val="475569"/>
+                </a:solidFill>
+                <a:latin typeface="Calibri"/>
+              </a:rPr>
+              <a:t>   • Live Mandi &amp; APMC Feeds: Real-time price tracking via e-NAM APIs for hyper-local commodity arbitrage guidance.</a:t>
+            </a:r>
+          </a:p>
+          <a:p>
+            <a:pPr>
+              <a:spcAft>
+                <a:spcPts val="200"/>
+              </a:spcAft>
+            </a:pPr>
+            <a:r>
+              <a:rPr sz="900" b="0">
+                <a:solidFill>
+                  <a:srgbClr val="475569"/>
+                </a:solidFill>
+                <a:latin typeface="Calibri"/>
+              </a:rPr>
+              <a:t>   • Offline PWA &amp; Edge AI: Local on-device LLM execution (Gemma 2B / WebLLM) for zero-connectivity deep rural villages.</a:t>
+            </a:r>
+          </a:p>
+          <a:p>
+            <a:pPr>
+              <a:spcAft>
+                <a:spcPts val="200"/>
+              </a:spcAft>
+            </a:pPr>
+            <a:r>
+              <a:rPr sz="900" b="0">
+                <a:solidFill>
+                  <a:srgbClr val="475569"/>
+                </a:solidFill>
+                <a:latin typeface="Calibri"/>
+              </a:rPr>
+              <a:t>   • SHG &amp; Cooperative Multi-Tenant Mode: Sizing pooled capital for Self-Help Groups and Village Milk Societies.</a:t>
+            </a:r>
+          </a:p>
+        </p:txBody>
+      </p:sp>
     </p:spTree>
   </p:cSld>
   <p:clrMapOvr>
@@ -15041,7 +14920,7 @@
       </p:pic>
       <p:pic>
         <p:nvPicPr>
-          <p:cNvPr id="120" name="Picture 119" descr="architecture_diagram.png"/>
+          <p:cNvPr id="120" name="Picture 119" descr="architecture_diagram_clean.png"/>
           <p:cNvPicPr>
             <a:picLocks noChangeAspect="1"/>
           </p:cNvPicPr>
@@ -15055,8 +14934,8 @@
         </p:blipFill>
         <p:spPr>
           <a:xfrm>
-            <a:off x="594360" y="1188720"/>
-            <a:ext cx="7955279" cy="3657600"/>
+            <a:off x="594360" y="1234440"/>
+            <a:ext cx="7955279" cy="3611880"/>
           </a:xfrm>
           <a:prstGeom prst="rect">
             <a:avLst/>
@@ -15182,38 +15061,18 @@
               <a:buSzPct val="120000"/>
               <a:buNone/>
             </a:pPr>
+            <a:endParaRPr sz="1800"/>
+          </a:p>
+          <a:p>
             <a:r>
-              <a:rPr b="1" lang="en-GB" sz="3000">
-                <a:solidFill>
-                  <a:schemeClr val="dk1"/>
-                </a:solidFill>
+              <a:rPr sz="2800" b="1">
+                <a:solidFill>
+                  <a:srgbClr val="0F172A"/>
+                </a:solidFill>
+                <a:latin typeface="Calibri"/>
               </a:rPr>
-              <a:t>Additional Details(</a:t>
+              <a:t>Additional Details</a:t>
             </a:r>
-            <a:r>
-              <a:rPr b="1" lang="en-GB" sz="1800">
-                <a:solidFill>
-                  <a:schemeClr val="dk1"/>
-                </a:solidFill>
-              </a:rPr>
-              <a:t>Kee</a:t>
-            </a:r>
-            <a:r>
-              <a:rPr b="1" lang="en-GB" sz="1800"/>
-              <a:t>p the content limited to</a:t>
-            </a:r>
-            <a:br>
-              <a:rPr b="1" lang="en-GB" sz="1800"/>
-            </a:br>
-            <a:r>
-              <a:rPr b="1" lang="en-GB" sz="1800"/>
-              <a:t>t</a:t>
-            </a:r>
-            <a:r>
-              <a:rPr b="1" lang="en-GB" sz="1800"/>
-              <a:t>his slide only)</a:t>
-            </a:r>
-            <a:endParaRPr sz="1800"/>
           </a:p>
         </p:txBody>
       </p:sp>
@@ -15225,8 +15084,8 @@
         </p:nvSpPr>
         <p:spPr>
           <a:xfrm>
-            <a:off x="548640" y="1097280"/>
-            <a:ext cx="3840480" cy="3749039"/>
+            <a:off x="640080" y="1280160"/>
+            <a:ext cx="3840480" cy="3566160"/>
           </a:xfrm>
           <a:prstGeom prst="rect">
             <a:avLst/>
@@ -15240,8 +15099,13 @@
           <a:lstStyle/>
           <a:p/>
           <a:p>
+            <a:pPr>
+              <a:spcAft>
+                <a:spcPts val="800"/>
+              </a:spcAft>
+            </a:pPr>
             <a:r>
-              <a:rPr sz="1150" b="1">
+              <a:rPr sz="1250" b="1">
                 <a:solidFill>
                   <a:srgbClr val="1E3A8A"/>
                 </a:solidFill>
@@ -15360,8 +15224,8 @@
         </p:nvSpPr>
         <p:spPr>
           <a:xfrm>
-            <a:off x="4663440" y="1097280"/>
-            <a:ext cx="3931920" cy="3749039"/>
+            <a:off x="4663440" y="1280160"/>
+            <a:ext cx="3840480" cy="3566160"/>
           </a:xfrm>
           <a:prstGeom prst="rect">
             <a:avLst/>
@@ -15375,8 +15239,13 @@
           <a:lstStyle/>
           <a:p/>
           <a:p>
+            <a:pPr>
+              <a:spcAft>
+                <a:spcPts val="800"/>
+              </a:spcAft>
+            </a:pPr>
             <a:r>
-              <a:rPr sz="1150" b="1">
+              <a:rPr sz="1250" b="1">
                 <a:solidFill>
                   <a:srgbClr val="1E3A8A"/>
                 </a:solidFill>

</xml_diff>

<commit_message>
fix(presentation): strictly adhere to 4 fields on slide 1, fix text readability, remove overlapping titles, and update 6-page PDF
</commit_message>
<xml_diff>
--- a/MD_Files/GramSaarthi_AI_Hackathon_Presentation.pptx
+++ b/MD_Files/GramSaarthi_AI_Hackathon_Presentation.pptx
@@ -12276,8 +12276,8 @@
         </p:nvSpPr>
         <p:spPr>
           <a:xfrm>
-            <a:off x="914400" y="1645920"/>
-            <a:ext cx="7315200" cy="2926080"/>
+            <a:off x="914400" y="1600200"/>
+            <a:ext cx="7315200" cy="3108960"/>
           </a:xfrm>
           <a:prstGeom prst="rect">
             <a:avLst/>
@@ -12288,20 +12288,20 @@
           </a:ln>
         </p:spPr>
         <p:txBody>
-          <a:bodyPr anchorCtr="0" anchor="ctr" bIns="34275" lIns="68575" spcFirstLastPara="1" rIns="68575" wrap="square" tIns="34275">
+          <a:bodyPr anchorCtr="0" anchor="ctr" bIns="54864" lIns="73152" spcFirstLastPara="1" rIns="73152" wrap="square" tIns="54864">
             <a:normAutofit/>
           </a:bodyPr>
           <a:lstStyle/>
           <a:p>
             <a:pPr indent="0" lvl="0" marL="0" marR="0" rtl="0" algn="l">
               <a:lnSpc>
-                <a:spcPct val="90000"/>
+                <a:spcPct val="115000"/>
               </a:lnSpc>
               <a:spcBef>
                 <a:spcPts val="800"/>
               </a:spcBef>
               <a:spcAft>
-                <a:spcPts val="0"/>
+                <a:spcPts val="1400"/>
               </a:spcAft>
               <a:buClr>
                 <a:schemeClr val="lt2"/>
@@ -12311,20 +12311,20 @@
               <a:buNone/>
             </a:pPr>
             <a:r>
-              <a:rPr sz="1300" b="1">
+              <a:rPr sz="1500" b="1">
                 <a:solidFill>
                   <a:srgbClr val="064E3B"/>
                 </a:solidFill>
-                <a:latin typeface="Arial"/>
+                <a:latin typeface="Calibri"/>
               </a:rPr>
               <a:t>Problem Statement Number : </a:t>
             </a:r>
             <a:r>
-              <a:rPr sz="1200" b="1">
+              <a:rPr sz="1450" b="1">
                 <a:solidFill>
                   <a:srgbClr val="0F172A"/>
                 </a:solidFill>
-                <a:latin typeface="Arial"/>
+                <a:latin typeface="Calibri"/>
               </a:rPr>
               <a:t>P11</a:t>
             </a:r>
@@ -12339,123 +12339,87 @@
             </a:endParaRPr>
           </a:p>
           <a:p>
+            <a:pPr>
+              <a:lnSpc>
+                <a:spcPct val="115000"/>
+              </a:lnSpc>
+              <a:spcAft>
+                <a:spcPts val="1400"/>
+              </a:spcAft>
+            </a:pPr>
             <a:r>
-              <a:rPr sz="1300" b="1">
+              <a:rPr sz="1500" b="1">
                 <a:solidFill>
                   <a:srgbClr val="064E3B"/>
                 </a:solidFill>
-                <a:latin typeface="Arial"/>
+                <a:latin typeface="Calibri"/>
               </a:rPr>
-              <a:t>Problem Statement Title : </a:t>
+              <a:t>Problem Statement Title: </a:t>
             </a:r>
             <a:r>
-              <a:rPr sz="1200" b="0">
+              <a:rPr sz="1450" b="0">
                 <a:solidFill>
                   <a:srgbClr val="0F172A"/>
                 </a:solidFill>
-                <a:latin typeface="Arial"/>
+                <a:latin typeface="Calibri"/>
               </a:rPr>
               <a:t>AI-Driven Hyper-Local Business Advisory and Financial Structuring Assistant for Rural Micro-Entrepreneurs</a:t>
             </a:r>
           </a:p>
           <a:p>
+            <a:pPr>
+              <a:lnSpc>
+                <a:spcPct val="115000"/>
+              </a:lnSpc>
+              <a:spcAft>
+                <a:spcPts val="1400"/>
+              </a:spcAft>
+            </a:pPr>
             <a:r>
-              <a:rPr sz="1300" b="1">
+              <a:rPr sz="1500" b="1">
                 <a:solidFill>
                   <a:srgbClr val="064E3B"/>
                 </a:solidFill>
-                <a:latin typeface="Arial"/>
+                <a:latin typeface="Calibri"/>
               </a:rPr>
-              <a:t>Project Name : </a:t>
+              <a:t>Team Name: </a:t>
             </a:r>
             <a:r>
-              <a:rPr sz="1200" b="1">
+              <a:rPr sz="1450" b="1">
                 <a:solidFill>
                   <a:srgbClr val="0F172A"/>
                 </a:solidFill>
-                <a:latin typeface="Arial"/>
+                <a:latin typeface="Calibri"/>
               </a:rPr>
-              <a:t>GramSaarthi AI (ग्रामसारथी) — National Micro-Enterprise Evaluation Engine</a:t>
+              <a:t>GramSaarthi AI</a:t>
             </a:r>
           </a:p>
           <a:p>
+            <a:pPr>
+              <a:lnSpc>
+                <a:spcPct val="115000"/>
+              </a:lnSpc>
+              <a:spcAft>
+                <a:spcPts val="1400"/>
+              </a:spcAft>
+            </a:pPr>
             <a:r>
-              <a:rPr sz="1300" b="1">
+              <a:rPr sz="1500" b="1">
                 <a:solidFill>
                   <a:srgbClr val="064E3B"/>
                 </a:solidFill>
-                <a:latin typeface="Arial"/>
+                <a:latin typeface="Calibri"/>
               </a:rPr>
-              <a:t>Team Leader Name : </a:t>
+              <a:t>Team Leader Name: </a:t>
             </a:r>
             <a:r>
-              <a:rPr sz="1200" b="1">
+              <a:rPr sz="1450" b="1">
                 <a:solidFill>
                   <a:srgbClr val="0F172A"/>
                 </a:solidFill>
-                <a:latin typeface="Arial"/>
+                <a:latin typeface="Calibri"/>
               </a:rPr>
               <a:t>Chirag Vasava</a:t>
-            </a:r>
-          </a:p>
-          <a:p>
-            <a:r>
-              <a:rPr sz="1300" b="1">
-                <a:solidFill>
-                  <a:srgbClr val="064E3B"/>
-                </a:solidFill>
-                <a:latin typeface="Arial"/>
-              </a:rPr>
-              <a:t>Live Cloud (AWS EC2) : </a:t>
-            </a:r>
-            <a:r>
-              <a:rPr sz="1200" b="0">
-                <a:solidFill>
-                  <a:srgbClr val="1D4ED8"/>
-                </a:solidFill>
-                <a:latin typeface="Arial"/>
-              </a:rPr>
-              <a:t>https://gramsaarthi-ai.chiragvasava.me</a:t>
-            </a:r>
-          </a:p>
-          <a:p>
-            <a:r>
-              <a:rPr sz="1300" b="1">
-                <a:solidFill>
-                  <a:srgbClr val="064E3B"/>
-                </a:solidFill>
-                <a:latin typeface="Arial"/>
-              </a:rPr>
-              <a:t>Live Edge (Vercel) : </a:t>
-            </a:r>
-            <a:r>
-              <a:rPr sz="1200" b="0">
-                <a:solidFill>
-                  <a:srgbClr val="1D4ED8"/>
-                </a:solidFill>
-                <a:latin typeface="Arial"/>
-              </a:rPr>
-              <a:t>https://gramsaarthi.chiragvasava.me</a:t>
-            </a:r>
-          </a:p>
-          <a:p>
-            <a:r>
-              <a:rPr sz="1300" b="1">
-                <a:solidFill>
-                  <a:srgbClr val="064E3B"/>
-                </a:solidFill>
-                <a:latin typeface="Arial"/>
-              </a:rPr>
-              <a:t>GitHub Repository : </a:t>
-            </a:r>
-            <a:r>
-              <a:rPr sz="1200" b="0">
-                <a:solidFill>
-                  <a:srgbClr val="1D4ED8"/>
-                </a:solidFill>
-                <a:latin typeface="Arial"/>
-              </a:rPr>
-              <a:t>https://github.com/ChiragVasava/gramsaarthi-ai</a:t>
             </a:r>
           </a:p>
         </p:txBody>
@@ -12665,8 +12629,8 @@
         </p:nvSpPr>
         <p:spPr>
           <a:xfrm>
-            <a:off x="640080" y="1280160"/>
-            <a:ext cx="3840480" cy="3566160"/>
+            <a:off x="594360" y="1188720"/>
+            <a:ext cx="3977639" cy="3703320"/>
           </a:xfrm>
           <a:prstGeom prst="rect">
             <a:avLst/>
@@ -12681,7 +12645,7 @@
           </a:ln>
         </p:spPr>
         <p:txBody>
-          <a:bodyPr anchorCtr="0" anchor="t" bIns="0" lIns="0" spcFirstLastPara="1" rIns="0" wrap="square" tIns="0">
+          <a:bodyPr anchorCtr="0" anchor="t" bIns="54864" lIns="73152" spcFirstLastPara="1" rIns="73152" wrap="square" tIns="54864">
             <a:noAutofit/>
           </a:bodyPr>
           <a:lstStyle/>
@@ -12694,7 +12658,7 @@
                 <a:spcPts val="0"/>
               </a:spcBef>
               <a:spcAft>
-                <a:spcPts val="0"/>
+                <a:spcPts val="600"/>
               </a:spcAft>
               <a:buClr>
                 <a:schemeClr val="lt2"/>
@@ -12702,14 +12666,14 @@
               <a:buSzPts val="1400"/>
               <a:buFont typeface="Arial"/>
               <a:buNone/>
-              <a:defRPr sz="1300" b="1">
-                <a:solidFill>
-                  <a:srgbClr val="064E3B"/>
-                </a:solidFill>
-                <a:latin typeface="Arial"/>
-              </a:defRPr>
             </a:pPr>
             <a:r>
+              <a:rPr sz="1300" b="1">
+                <a:solidFill>
+                  <a:srgbClr val="064E3B"/>
+                </a:solidFill>
+                <a:latin typeface="Calibri"/>
+              </a:rPr>
               <a:t>Describe your Idea/Solution/Prototype here:</a:t>
             </a:r>
             <a:endParaRPr b="0" i="0" sz="1500" u="none" cap="none" strike="noStrike">
@@ -12724,80 +12688,170 @@
           </a:p>
           <a:p>
             <a:pPr>
-              <a:defRPr sz="1019" b="0">
-                <a:solidFill>
-                  <a:srgbClr val="0F172A"/>
-                </a:solidFill>
-                <a:latin typeface="Arial"/>
-              </a:defRPr>
+              <a:lnSpc>
+                <a:spcPct val="108000"/>
+              </a:lnSpc>
+              <a:spcAft>
+                <a:spcPts val="500"/>
+              </a:spcAft>
             </a:pPr>
             <a:r>
-              <a:t>• Core Problem Addressed: Over 63M rural micro-entrepreneurs face a 40%+ failure rate due to informal hearsay, zero local market data, and 78% rejection in statutory bank credit schemes.</a:t>
+              <a:rPr sz="1080" b="1">
+                <a:solidFill>
+                  <a:srgbClr val="0F172A"/>
+                </a:solidFill>
+                <a:latin typeface="Calibri"/>
+              </a:rPr>
+              <a:t>• The Rural Problem: </a:t>
+            </a:r>
+            <a:r>
+              <a:rPr sz="1050" b="0">
+                <a:solidFill>
+                  <a:srgbClr val="1E293B"/>
+                </a:solidFill>
+                <a:latin typeface="Calibri"/>
+              </a:rPr>
+              <a:t>Over 63M micro-enterprises face 40%+ failure rates due to informal hearsay and 78% credit rejection by banks.</a:t>
             </a:r>
           </a:p>
           <a:p>
             <a:pPr>
-              <a:defRPr sz="1019" b="0">
-                <a:solidFill>
-                  <a:srgbClr val="0F172A"/>
-                </a:solidFill>
-                <a:latin typeface="Arial"/>
-              </a:defRPr>
+              <a:lnSpc>
+                <a:spcPct val="108000"/>
+              </a:lnSpc>
+              <a:spcAft>
+                <a:spcPts val="500"/>
+              </a:spcAft>
             </a:pPr>
             <a:r>
-              <a:t>• GramSaarthi AI Solution: An intelligent trilingual rural advisory platform combining two decoupled core modules:</a:t>
+              <a:rPr sz="1080" b="1">
+                <a:solidFill>
+                  <a:srgbClr val="0F172A"/>
+                </a:solidFill>
+                <a:latin typeface="Calibri"/>
+              </a:rPr>
+              <a:t>• GramSaarthi AI Solution: </a:t>
+            </a:r>
+            <a:r>
+              <a:rPr sz="1050" b="0">
+                <a:solidFill>
+                  <a:srgbClr val="1E293B"/>
+                </a:solidFill>
+                <a:latin typeface="Calibri"/>
+              </a:rPr>
+              <a:t>An institutional-grade rural advisory platform featuring two decoupled core engines:</a:t>
             </a:r>
           </a:p>
           <a:p>
             <a:pPr>
-              <a:defRPr sz="980" b="0">
-                <a:solidFill>
-                  <a:srgbClr val="0F172A"/>
-                </a:solidFill>
-                <a:latin typeface="Arial"/>
-              </a:defRPr>
+              <a:lnSpc>
+                <a:spcPct val="108000"/>
+              </a:lnSpc>
+              <a:spcAft>
+                <a:spcPts val="300"/>
+              </a:spcAft>
             </a:pPr>
             <a:r>
-              <a:t>  1. Hyper-Local Feasibility Engine: Analyzes 5 km &amp; 10 km spatial catchment zones, demographic density, trade-adaptive POIs (mandis, chillers), and empirical SWOT matrices.</a:t>
+              <a:rPr sz="1019" b="1">
+                <a:solidFill>
+                  <a:srgbClr val="0F172A"/>
+                </a:solidFill>
+                <a:latin typeface="Calibri"/>
+              </a:rPr>
+              <a:t>    1. Spatial Feasibility: </a:t>
+            </a:r>
+            <a:r>
+              <a:rPr sz="1019" b="0">
+                <a:solidFill>
+                  <a:srgbClr val="1E293B"/>
+                </a:solidFill>
+                <a:latin typeface="Calibri"/>
+              </a:rPr>
+              <a:t>Analyzes 5 km &amp; 10 km catchment demand, trade-adaptive POIs (mandis, chillers), and empirical SWOT.</a:t>
             </a:r>
           </a:p>
           <a:p>
             <a:pPr>
-              <a:defRPr sz="980" b="0">
-                <a:solidFill>
-                  <a:srgbClr val="0F172A"/>
-                </a:solidFill>
-                <a:latin typeface="Arial"/>
-              </a:defRPr>
+              <a:lnSpc>
+                <a:spcPct val="108000"/>
+              </a:lnSpc>
+              <a:spcAft>
+                <a:spcPts val="300"/>
+              </a:spcAft>
             </a:pPr>
             <a:r>
-              <a:t>  2. Statutory Financial Structuring: Deterministic debt sizing (10% Margin, 90% Loan), automated scheme routing (Micro Finance @ 6.5% vs. Term Loan @ 8.0%), and moratorium debt amortization.</a:t>
+              <a:rPr sz="1019" b="1">
+                <a:solidFill>
+                  <a:srgbClr val="0F172A"/>
+                </a:solidFill>
+                <a:latin typeface="Calibri"/>
+              </a:rPr>
+              <a:t>    2. Statutory Debt Sizing: </a:t>
+            </a:r>
+            <a:r>
+              <a:rPr sz="1019" b="0">
+                <a:solidFill>
+                  <a:srgbClr val="1E293B"/>
+                </a:solidFill>
+                <a:latin typeface="Calibri"/>
+              </a:rPr>
+              <a:t>Strict 10% equity commits, automated scheme qualification, and grace period amortization.</a:t>
             </a:r>
           </a:p>
           <a:p>
             <a:pPr>
-              <a:defRPr sz="1019" b="0">
-                <a:solidFill>
-                  <a:srgbClr val="0F172A"/>
-                </a:solidFill>
-                <a:latin typeface="Arial"/>
-              </a:defRPr>
+              <a:lnSpc>
+                <a:spcPct val="108000"/>
+              </a:lnSpc>
+              <a:spcAft>
+                <a:spcPts val="500"/>
+              </a:spcAft>
             </a:pPr>
             <a:r>
-              <a:t>• Multi-Enterprise Portfolio: Supports creating, comparing, and managing multiple business appraisals (e.g. Dairy + Flour Milling) with cross-app real-time synchronization.</a:t>
+              <a:rPr sz="1080" b="1">
+                <a:solidFill>
+                  <a:srgbClr val="0F172A"/>
+                </a:solidFill>
+                <a:latin typeface="Calibri"/>
+              </a:rPr>
+              <a:t>• Multi-Enterprise Portfolio: </a:t>
+            </a:r>
+            <a:r>
+              <a:rPr sz="1050" b="0">
+                <a:solidFill>
+                  <a:srgbClr val="1E293B"/>
+                </a:solidFill>
+                <a:latin typeface="Calibri"/>
+              </a:rPr>
+              <a:t>Evaluate and switch multiple businesses (Dairy, Food Processing, Retail) with live synchronized context.</a:t>
             </a:r>
           </a:p>
           <a:p>
             <a:pPr>
-              <a:defRPr sz="1019" b="0">
-                <a:solidFill>
-                  <a:srgbClr val="0F172A"/>
-                </a:solidFill>
-                <a:latin typeface="Arial"/>
-              </a:defRPr>
+              <a:lnSpc>
+                <a:spcPct val="108000"/>
+              </a:lnSpc>
+              <a:spcAft>
+                <a:spcPts val="500"/>
+              </a:spcAft>
             </a:pPr>
             <a:r>
-              <a:t>• 1-Click Direct PDF Engine: Client-side Canvas2D color proxy converts modern CSS color spaces (lab, oklch), generating bankable dossiers in &lt;1.5s with zero print dialogs.</a:t>
+              <a:rPr sz="1080" b="1">
+                <a:solidFill>
+                  <a:srgbClr val="0F172A"/>
+                </a:solidFill>
+                <a:latin typeface="Calibri"/>
+              </a:rPr>
+              <a:t>• 1-Click Direct PDF Dossier: </a:t>
+            </a:r>
+            <a:r>
+              <a:rPr sz="1050" b="0">
+                <a:solidFill>
+                  <a:srgbClr val="1E293B"/>
+                </a:solidFill>
+                <a:latin typeface="Calibri"/>
+              </a:rPr>
+              <a:t>Instant client-side download in &lt;2s with zero print dialogs via Canvas2D color proxy.</a:t>
             </a:r>
           </a:p>
         </p:txBody>
@@ -12828,7 +12882,26 @@
             <a:noAutofit/>
           </a:bodyPr>
           <a:lstStyle/>
-          <a:p/>
+          <a:p>
+            <a:pPr indent="0" lvl="0" marL="0" rtl="0" algn="r">
+              <a:lnSpc>
+                <a:spcPct val="100000"/>
+              </a:lnSpc>
+              <a:spcBef>
+                <a:spcPts val="0"/>
+              </a:spcBef>
+              <a:spcAft>
+                <a:spcPts val="0"/>
+              </a:spcAft>
+              <a:buSzPts val="1000"/>
+              <a:buNone/>
+            </a:pPr>
+            <a:fld id="{00000000-1234-1234-1234-123412341234}" type="slidenum">
+              <a:rPr lang="en-GB"/>
+              <a:t>‹#›</a:t>
+            </a:fld>
+            <a:endParaRPr/>
+          </a:p>
         </p:txBody>
       </p:sp>
       <p:sp>
@@ -12839,8 +12912,8 @@
         </p:nvSpPr>
         <p:spPr>
           <a:xfrm>
-            <a:off x="4663440" y="1280160"/>
-            <a:ext cx="3840480" cy="3566160"/>
+            <a:off x="4709160" y="1188720"/>
+            <a:ext cx="3977639" cy="3703320"/>
           </a:xfrm>
           <a:prstGeom prst="rect">
             <a:avLst/>
@@ -12855,7 +12928,7 @@
           </a:ln>
         </p:spPr>
         <p:txBody>
-          <a:bodyPr anchorCtr="0" anchor="t" bIns="0" lIns="0" spcFirstLastPara="1" rIns="0" wrap="square" tIns="0">
+          <a:bodyPr anchorCtr="0" anchor="t" bIns="54864" lIns="73152" spcFirstLastPara="1" rIns="73152" wrap="square" tIns="54864">
             <a:noAutofit/>
           </a:bodyPr>
           <a:lstStyle/>
@@ -12868,7 +12941,7 @@
                 <a:spcPts val="0"/>
               </a:spcBef>
               <a:spcAft>
-                <a:spcPts val="0"/>
+                <a:spcPts val="600"/>
               </a:spcAft>
               <a:buClr>
                 <a:schemeClr val="lt2"/>
@@ -12876,14 +12949,14 @@
               <a:buSzPts val="1400"/>
               <a:buFont typeface="Arial"/>
               <a:buNone/>
-              <a:defRPr sz="1300" b="1">
-                <a:solidFill>
-                  <a:srgbClr val="064E3B"/>
-                </a:solidFill>
-                <a:latin typeface="Arial"/>
-              </a:defRPr>
             </a:pPr>
             <a:r>
+              <a:rPr sz="1300" b="1">
+                <a:solidFill>
+                  <a:srgbClr val="064E3B"/>
+                </a:solidFill>
+                <a:latin typeface="Calibri"/>
+              </a:rPr>
               <a:t>Describe your Technology stack here:</a:t>
             </a:r>
             <a:endParaRPr b="0" i="0" sz="1500" u="none" cap="none" strike="noStrike">
@@ -12898,93 +12971,170 @@
           </a:p>
           <a:p>
             <a:pPr>
-              <a:defRPr sz="1019" b="0">
-                <a:solidFill>
-                  <a:srgbClr val="0F172A"/>
-                </a:solidFill>
-                <a:latin typeface="Arial"/>
-              </a:defRPr>
+              <a:lnSpc>
+                <a:spcPct val="110000"/>
+              </a:lnSpc>
+              <a:spcAft>
+                <a:spcPts val="600"/>
+              </a:spcAft>
             </a:pPr>
             <a:r>
-              <a:t>• Next.js 16 (React 19 App Router): Fast server-side rendering, modular client routing, and production build.</a:t>
+              <a:rPr sz="1080" b="1">
+                <a:solidFill>
+                  <a:srgbClr val="0F172A"/>
+                </a:solidFill>
+                <a:latin typeface="Calibri"/>
+              </a:rPr>
+              <a:t>• Frontend / UX: </a:t>
+            </a:r>
+            <a:r>
+              <a:rPr sz="1050" b="0">
+                <a:solidFill>
+                  <a:srgbClr val="1E293B"/>
+                </a:solidFill>
+                <a:latin typeface="Calibri"/>
+              </a:rPr>
+              <a:t>Next.js 16 (React 19 App Router) with TypeScript 5 &amp; Tailwind CSS.</a:t>
             </a:r>
           </a:p>
           <a:p>
             <a:pPr>
-              <a:defRPr sz="1019" b="0">
-                <a:solidFill>
-                  <a:srgbClr val="0F172A"/>
-                </a:solidFill>
-                <a:latin typeface="Arial"/>
-              </a:defRPr>
+              <a:lnSpc>
+                <a:spcPct val="110000"/>
+              </a:lnSpc>
+              <a:spcAft>
+                <a:spcPts val="600"/>
+              </a:spcAft>
             </a:pPr>
             <a:r>
-              <a:t>• TypeScript 5: Strict mathematical type-safety across financial formulas, eliminating floating-point errors.</a:t>
+              <a:rPr sz="1080" b="1">
+                <a:solidFill>
+                  <a:srgbClr val="0F172A"/>
+                </a:solidFill>
+                <a:latin typeface="Calibri"/>
+              </a:rPr>
+              <a:t>• Multi-Report Engine: </a:t>
+            </a:r>
+            <a:r>
+              <a:rPr sz="1050" b="0">
+                <a:solidFill>
+                  <a:srgbClr val="1E293B"/>
+                </a:solidFill>
+                <a:latin typeface="Calibri"/>
+              </a:rPr>
+              <a:t>Custom reactive store (lib/report-store.ts) with SQLite / Prisma ORM persistence.</a:t>
             </a:r>
           </a:p>
           <a:p>
             <a:pPr>
-              <a:defRPr sz="1019" b="0">
-                <a:solidFill>
-                  <a:srgbClr val="0F172A"/>
-                </a:solidFill>
-                <a:latin typeface="Arial"/>
-              </a:defRPr>
+              <a:lnSpc>
+                <a:spcPct val="110000"/>
+              </a:lnSpc>
+              <a:spcAft>
+                <a:spcPts val="600"/>
+              </a:spcAft>
             </a:pPr>
             <a:r>
-              <a:t>• Multi-Report State Engine: lib/report-store.ts with custom gs_report_changed reactive event bus &amp; SQLite / Prisma ORM.</a:t>
+              <a:rPr sz="1080" b="1">
+                <a:solidFill>
+                  <a:srgbClr val="0F172A"/>
+                </a:solidFill>
+                <a:latin typeface="Calibri"/>
+              </a:rPr>
+              <a:t>• Deterministic Math: </a:t>
+            </a:r>
+            <a:r>
+              <a:rPr sz="1050" b="0">
+                <a:solidFill>
+                  <a:srgbClr val="1E293B"/>
+                </a:solidFill>
+                <a:latin typeface="Calibri"/>
+              </a:rPr>
+              <a:t>Pure TypeScript statutory engine for debt sizing and moratorium schedules (zero hallucination).</a:t>
             </a:r>
           </a:p>
           <a:p>
             <a:pPr>
-              <a:defRPr sz="1019" b="0">
-                <a:solidFill>
-                  <a:srgbClr val="0F172A"/>
-                </a:solidFill>
-                <a:latin typeface="Arial"/>
-              </a:defRPr>
+              <a:lnSpc>
+                <a:spcPct val="110000"/>
+              </a:lnSpc>
+              <a:spcAft>
+                <a:spcPts val="600"/>
+              </a:spcAft>
             </a:pPr>
             <a:r>
-              <a:t>• Dual-Cloud Production: AWS EC2 (Docker, Caddy Reverse Proxy, HTTP/2 &amp; Auto-TLS on 13.126.176.46) + Vercel Edge.</a:t>
+              <a:rPr sz="1080" b="1">
+                <a:solidFill>
+                  <a:srgbClr val="0F172A"/>
+                </a:solidFill>
+                <a:latin typeface="Calibri"/>
+              </a:rPr>
+              <a:t>• AI &amp; Voice Desk: </a:t>
+            </a:r>
+            <a:r>
+              <a:rPr sz="1050" b="0">
+                <a:solidFill>
+                  <a:srgbClr val="1E293B"/>
+                </a:solidFill>
+                <a:latin typeface="Calibri"/>
+              </a:rPr>
+              <a:t>Google Gemini API with strict domain guardrails, Web Speech API, trilingual (EN, HI, GU).</a:t>
             </a:r>
           </a:p>
           <a:p>
             <a:pPr>
-              <a:defRPr sz="1019" b="0">
-                <a:solidFill>
-                  <a:srgbClr val="0F172A"/>
-                </a:solidFill>
-                <a:latin typeface="Arial"/>
-              </a:defRPr>
+              <a:lnSpc>
+                <a:spcPct val="110000"/>
+              </a:lnSpc>
+              <a:spcAft>
+                <a:spcPts val="600"/>
+              </a:spcAft>
             </a:pPr>
             <a:r>
-              <a:t>• Infrastructure as Code: 100% declarative Terraform automation (terraform apply) for reproducible cloud provisioning.</a:t>
+              <a:rPr sz="1080" b="1">
+                <a:solidFill>
+                  <a:srgbClr val="0F172A"/>
+                </a:solidFill>
+                <a:latin typeface="Calibri"/>
+              </a:rPr>
+              <a:t>• Vector PDF Engine: </a:t>
+            </a:r>
+            <a:r>
+              <a:rPr sz="1050" b="0">
+                <a:solidFill>
+                  <a:srgbClr val="1E293B"/>
+                </a:solidFill>
+                <a:latin typeface="Calibri"/>
+              </a:rPr>
+              <a:t>jsPDF + html2canvas with offscreen Canvas2D RGBA color space proxy.</a:t>
             </a:r>
           </a:p>
           <a:p>
             <a:pPr>
-              <a:defRPr sz="1019" b="0">
-                <a:solidFill>
-                  <a:srgbClr val="0F172A"/>
-                </a:solidFill>
-                <a:latin typeface="Arial"/>
-              </a:defRPr>
+              <a:lnSpc>
+                <a:spcPct val="110000"/>
+              </a:lnSpc>
+              <a:spcAft>
+                <a:spcPts val="600"/>
+              </a:spcAft>
             </a:pPr>
             <a:r>
-              <a:t>• AI &amp; Voice Accessibility: Google Gemini API with strict domain guardrails, Web Speech API, trilingual (EN, HI, GU).</a:t>
+              <a:rPr sz="1080" b="1">
+                <a:solidFill>
+                  <a:srgbClr val="0F172A"/>
+                </a:solidFill>
+                <a:latin typeface="Calibri"/>
+              </a:rPr>
+              <a:t>• Production DevOps: </a:t>
             </a:r>
-          </a:p>
-          <a:p>
-            <a:pPr>
-              <a:defRPr sz="1019" b="0">
-                <a:solidFill>
-                  <a:srgbClr val="0F172A"/>
-                </a:solidFill>
-                <a:latin typeface="Arial"/>
-              </a:defRPr>
-            </a:pPr>
             <a:r>
-              <a:t>• Vector PDF Engine: jsPDF + html2canvas with offscreen Canvas2D RGBA color space proxy.</a:t>
+              <a:rPr sz="1050" b="0">
+                <a:solidFill>
+                  <a:srgbClr val="1E293B"/>
+                </a:solidFill>
+                <a:latin typeface="Calibri"/>
+              </a:rPr>
+              <a:t>AWS EC2 containerized with Docker, Caddy reverse proxy (Auto-TLS), and Terraform IaC.</a:t>
             </a:r>
           </a:p>
         </p:txBody>
@@ -13256,8 +13406,8 @@
         </p:nvSpPr>
         <p:spPr>
           <a:xfrm>
-            <a:off x="640080" y="1280160"/>
-            <a:ext cx="3840480" cy="365760"/>
+            <a:off x="594360" y="1188720"/>
+            <a:ext cx="3977639" cy="320040"/>
           </a:xfrm>
           <a:prstGeom prst="rect">
             <a:avLst/>
@@ -13268,7 +13418,7 @@
           </a:ln>
         </p:spPr>
         <p:txBody>
-          <a:bodyPr anchorCtr="0" anchor="t" bIns="34275" lIns="68575" spcFirstLastPara="1" rIns="68575" wrap="square" tIns="34275">
+          <a:bodyPr anchorCtr="0" anchor="t" bIns="54864" lIns="73152" spcFirstLastPara="1" rIns="73152" wrap="square" tIns="54864">
             <a:noAutofit/>
           </a:bodyPr>
           <a:lstStyle/>
@@ -13290,6 +13440,15 @@
               <a:buFont typeface="Arial"/>
               <a:buNone/>
             </a:pPr>
+            <a:r>
+              <a:rPr sz="1300" b="1">
+                <a:solidFill>
+                  <a:srgbClr val="064E3B"/>
+                </a:solidFill>
+                <a:latin typeface="Calibri"/>
+              </a:rPr>
+              <a:t>Describe your Use Cases here</a:t>
+            </a:r>
             <a:endParaRPr b="0" i="0" sz="1100" u="none" cap="none" strike="noStrike">
               <a:solidFill>
                 <a:srgbClr val="000000"/>
@@ -13299,17 +13458,6 @@
               <a:cs typeface="Arial"/>
               <a:sym typeface="Arial"/>
             </a:endParaRPr>
-          </a:p>
-          <a:p>
-            <a:r>
-              <a:rPr sz="1250" b="1">
-                <a:solidFill>
-                  <a:srgbClr val="1E3A8A"/>
-                </a:solidFill>
-                <a:latin typeface="Calibri"/>
-              </a:rPr>
-              <a:t>Describe your Use Cases here</a:t>
-            </a:r>
           </a:p>
         </p:txBody>
       </p:sp>
@@ -13321,8 +13469,8 @@
         </p:nvSpPr>
         <p:spPr>
           <a:xfrm>
-            <a:off x="640080" y="1691640"/>
-            <a:ext cx="3840480" cy="3154680"/>
+            <a:off x="594360" y="1554480"/>
+            <a:ext cx="3977639" cy="3337560"/>
           </a:xfrm>
           <a:prstGeom prst="rect">
             <a:avLst/>
@@ -13337,7 +13485,7 @@
           </a:ln>
         </p:spPr>
         <p:txBody>
-          <a:bodyPr anchorCtr="0" anchor="t" bIns="34275" lIns="68575" spcFirstLastPara="1" rIns="68575" wrap="square" tIns="34275">
+          <a:bodyPr anchorCtr="0" anchor="t" bIns="54864" lIns="73152" spcFirstLastPara="1" rIns="73152" wrap="square" tIns="54864">
             <a:noAutofit/>
           </a:bodyPr>
           <a:lstStyle/>
@@ -13350,7 +13498,7 @@
                 <a:spcPts val="0"/>
               </a:spcBef>
               <a:spcAft>
-                <a:spcPts val="0"/>
+                <a:spcPts val="200"/>
               </a:spcAft>
               <a:buClr>
                 <a:srgbClr val="000000"/>
@@ -13358,15 +13506,15 @@
               <a:buSzPts val="1100"/>
               <a:buFont typeface="Arial"/>
               <a:buNone/>
-              <a:defRPr sz="1050" b="1">
-                <a:solidFill>
-                  <a:srgbClr val="064E3B"/>
-                </a:solidFill>
-                <a:latin typeface="Arial"/>
-              </a:defRPr>
             </a:pPr>
             <a:r>
-              <a:t>▶ Dairy / Livestock Enterprise (Savli, Vadodara):</a:t>
+              <a:rPr sz="1100" b="1">
+                <a:solidFill>
+                  <a:srgbClr val="064E3B"/>
+                </a:solidFill>
+                <a:latin typeface="Calibri"/>
+              </a:rPr>
+              <a:t>▶ 1. Dairy Enterprise Appraisal (Savli, Vadodara):</a:t>
             </a:r>
             <a:endParaRPr b="0" i="0" sz="1100" u="none" cap="none" strike="noStrike">
               <a:solidFill>
@@ -13380,132 +13528,126 @@
           </a:p>
           <a:p>
             <a:pPr>
-              <a:defRPr sz="980" b="0">
-                <a:solidFill>
-                  <a:srgbClr val="0F172A"/>
-                </a:solidFill>
-                <a:latin typeface="Arial"/>
-              </a:defRPr>
+              <a:lnSpc>
+                <a:spcPct val="108000"/>
+              </a:lnSpc>
+              <a:spcAft>
+                <a:spcPts val="500"/>
+              </a:spcAft>
             </a:pPr>
             <a:r>
-              <a:t>• Margin: ₹1,00,000 sizes ₹10,00,000 project &amp; ₹9,00,000 loan under Term Loan Scheme (8.0% p.a., 7 yrs, 6-mo grace).</a:t>
+              <a:rPr sz="1040" b="0">
+                <a:solidFill>
+                  <a:srgbClr val="1E293B"/>
+                </a:solidFill>
+                <a:latin typeface="Calibri"/>
+              </a:rPr>
+              <a:t>• ₹1 Lakh margin sizes ₹10 Lakh project &amp; ₹9 Lakh loan under Term Loan Scheme (8.0% p.a., 7 yrs, 6-mo grace); maps 5 km milk chilling hubs.</a:t>
             </a:r>
           </a:p>
           <a:p>
             <a:pPr>
-              <a:defRPr sz="980" b="0">
-                <a:solidFill>
-                  <a:srgbClr val="0F172A"/>
-                </a:solidFill>
-                <a:latin typeface="Arial"/>
-              </a:defRPr>
+              <a:spcAft>
+                <a:spcPts val="200"/>
+              </a:spcAft>
             </a:pPr>
             <a:r>
-              <a:t>• Spatial radar evaluates 5 km milk chilling hubs, cooperatives, and veterinary clinics.</a:t>
+              <a:rPr sz="1100" b="1">
+                <a:solidFill>
+                  <a:srgbClr val="064E3B"/>
+                </a:solidFill>
+                <a:latin typeface="Calibri"/>
+              </a:rPr>
+              <a:t>▶ 2. Food Processing &amp; Flour Milling (Padra):</a:t>
             </a:r>
           </a:p>
           <a:p>
             <a:pPr>
-              <a:defRPr sz="1050" b="1">
-                <a:solidFill>
-                  <a:srgbClr val="064E3B"/>
-                </a:solidFill>
-                <a:latin typeface="Arial"/>
-              </a:defRPr>
+              <a:lnSpc>
+                <a:spcPct val="108000"/>
+              </a:lnSpc>
+              <a:spcAft>
+                <a:spcPts val="500"/>
+              </a:spcAft>
             </a:pPr>
             <a:r>
-              <a:t>▶ Food Processing &amp; Flour Milling (Padra, Vadodara):</a:t>
+              <a:rPr sz="1040" b="0">
+                <a:solidFill>
+                  <a:srgbClr val="1E293B"/>
+                </a:solidFill>
+                <a:latin typeface="Calibri"/>
+              </a:rPr>
+              <a:t>• ₹12,000 margin sizes ₹1.20 Lakh project &amp; ₹1.08 Lakh loan under Micro Finance Scheme (6.5% p.a., 3 yrs, 3-mo grace); models grain inventory buffer.</a:t>
             </a:r>
           </a:p>
           <a:p>
             <a:pPr>
-              <a:defRPr sz="980" b="0">
-                <a:solidFill>
-                  <a:srgbClr val="0F172A"/>
-                </a:solidFill>
-                <a:latin typeface="Arial"/>
-              </a:defRPr>
+              <a:spcAft>
+                <a:spcPts val="200"/>
+              </a:spcAft>
             </a:pPr>
             <a:r>
-              <a:t>• Sizes ₹1,20,000 project with ₹12,000 margin under Micro Finance Scheme (6.5% p.a., 3 yrs, 3-mo grace).</a:t>
+              <a:rPr sz="1100" b="1">
+                <a:solidFill>
+                  <a:srgbClr val="064E3B"/>
+                </a:solidFill>
+                <a:latin typeface="Calibri"/>
+              </a:rPr>
+              <a:t>▶ 3. Multi-Enterprise Portfolio Management:</a:t>
             </a:r>
           </a:p>
           <a:p>
             <a:pPr>
-              <a:defRPr sz="980" b="0">
-                <a:solidFill>
-                  <a:srgbClr val="0F172A"/>
-                </a:solidFill>
-                <a:latin typeface="Arial"/>
-              </a:defRPr>
+              <a:lnSpc>
+                <a:spcPct val="108000"/>
+              </a:lnSpc>
+              <a:spcAft>
+                <a:spcPts val="500"/>
+              </a:spcAft>
             </a:pPr>
             <a:r>
-              <a:t>• Models 3-month working capital buffer for raw grain procurement.</a:t>
+              <a:rPr sz="1040" b="0">
+                <a:solidFill>
+                  <a:srgbClr val="1E293B"/>
+                </a:solidFill>
+                <a:latin typeface="Calibri"/>
+              </a:rPr>
+              <a:t>• Entrepreneurs toggle between ventures; Dashboard aggregates combined investment (₹11.20L) and loan eligibility (₹10.08L).</a:t>
             </a:r>
           </a:p>
           <a:p>
             <a:pPr>
-              <a:defRPr sz="1050" b="1">
-                <a:solidFill>
-                  <a:srgbClr val="B45309"/>
-                </a:solidFill>
-                <a:latin typeface="Arial"/>
-              </a:defRPr>
+              <a:spcAft>
+                <a:spcPts val="200"/>
+              </a:spcAft>
             </a:pPr>
             <a:r>
-              <a:t>▶ Multi-Enterprise Portfolio Management:</a:t>
+              <a:rPr sz="1100" b="1">
+                <a:solidFill>
+                  <a:srgbClr val="064E3B"/>
+                </a:solidFill>
+                <a:latin typeface="Calibri"/>
+              </a:rPr>
+              <a:t>▶ 4. Trilingual Voice Advisory for Bharat:</a:t>
             </a:r>
           </a:p>
           <a:p>
             <a:pPr>
-              <a:defRPr sz="980" b="0">
-                <a:solidFill>
-                  <a:srgbClr val="0F172A"/>
-                </a:solidFill>
-                <a:latin typeface="Arial"/>
-              </a:defRPr>
+              <a:lnSpc>
+                <a:spcPct val="108000"/>
+              </a:lnSpc>
+              <a:spcAft>
+                <a:spcPts val="500"/>
+              </a:spcAft>
             </a:pPr>
             <a:r>
-              <a:t>• Entrepreneur toggles between ventures on Dashboard, Map, Calculator, and Chat.</a:t>
-            </a:r>
-          </a:p>
-          <a:p>
-            <a:pPr>
-              <a:defRPr sz="980" b="0">
-                <a:solidFill>
-                  <a:srgbClr val="0F172A"/>
-                </a:solidFill>
-                <a:latin typeface="Arial"/>
-              </a:defRPr>
-            </a:pPr>
-            <a:r>
-              <a:t>• Aggregates combined investment (₹11.20L) and total credit eligibility (₹10.08L).</a:t>
-            </a:r>
-          </a:p>
-          <a:p>
-            <a:pPr>
-              <a:defRPr sz="1050" b="1">
-                <a:solidFill>
-                  <a:srgbClr val="064E3B"/>
-                </a:solidFill>
-                <a:latin typeface="Arial"/>
-              </a:defRPr>
-            </a:pPr>
-            <a:r>
-              <a:t>▶ Trilingual Guardrailed Advisory for Bharat:</a:t>
-            </a:r>
-          </a:p>
-          <a:p>
-            <a:pPr>
-              <a:defRPr sz="980" b="0">
-                <a:solidFill>
-                  <a:srgbClr val="0F172A"/>
-                </a:solidFill>
-                <a:latin typeface="Arial"/>
-              </a:defRPr>
-            </a:pPr>
-            <a:r>
-              <a:t>• Voice Q&amp;A in Hindi/Gujarati; guardrails reject off-topic coding/trivia queries.</a:t>
+              <a:rPr sz="1040" b="0">
+                <a:solidFill>
+                  <a:srgbClr val="1E293B"/>
+                </a:solidFill>
+                <a:latin typeface="Calibri"/>
+              </a:rPr>
+              <a:t>• Voice Q&amp;A in Hindi &amp; Gujarati with strict guardrails rejecting off-topic coding/trivia queries.</a:t>
             </a:r>
           </a:p>
         </p:txBody>
@@ -13518,8 +13660,8 @@
         </p:nvSpPr>
         <p:spPr>
           <a:xfrm>
-            <a:off x="4663440" y="1280160"/>
-            <a:ext cx="3840480" cy="365760"/>
+            <a:off x="4709160" y="1188720"/>
+            <a:ext cx="3977639" cy="320040"/>
           </a:xfrm>
           <a:prstGeom prst="rect">
             <a:avLst/>
@@ -13530,7 +13672,7 @@
           </a:ln>
         </p:spPr>
         <p:txBody>
-          <a:bodyPr anchorCtr="0" anchor="t" bIns="34275" lIns="68575" spcFirstLastPara="1" rIns="68575" wrap="square" tIns="34275">
+          <a:bodyPr anchorCtr="0" anchor="t" bIns="54864" lIns="73152" spcFirstLastPara="1" rIns="73152" wrap="square" tIns="54864">
             <a:noAutofit/>
           </a:bodyPr>
           <a:lstStyle/>
@@ -13552,6 +13694,15 @@
               <a:buFont typeface="Arial"/>
               <a:buNone/>
             </a:pPr>
+            <a:r>
+              <a:rPr sz="1300" b="1">
+                <a:solidFill>
+                  <a:srgbClr val="064E3B"/>
+                </a:solidFill>
+                <a:latin typeface="Calibri"/>
+              </a:rPr>
+              <a:t>Describe your Dependencies</a:t>
+            </a:r>
             <a:endParaRPr b="0" i="0" sz="1500" u="none" cap="none" strike="noStrike">
               <a:solidFill>
                 <a:schemeClr val="dk1"/>
@@ -13561,17 +13712,6 @@
               <a:cs typeface="Franklin Gothic"/>
               <a:sym typeface="Franklin Gothic"/>
             </a:endParaRPr>
-          </a:p>
-          <a:p>
-            <a:r>
-              <a:rPr sz="1250" b="1">
-                <a:solidFill>
-                  <a:srgbClr val="1E3A8A"/>
-                </a:solidFill>
-                <a:latin typeface="Calibri"/>
-              </a:rPr>
-              <a:t>Describe your Dependencies</a:t>
-            </a:r>
           </a:p>
         </p:txBody>
       </p:sp>
@@ -13583,8 +13723,8 @@
         </p:nvSpPr>
         <p:spPr>
           <a:xfrm>
-            <a:off x="4663440" y="1691640"/>
-            <a:ext cx="3840480" cy="3154680"/>
+            <a:off x="4709160" y="1554480"/>
+            <a:ext cx="3977639" cy="3337560"/>
           </a:xfrm>
           <a:prstGeom prst="rect">
             <a:avLst/>
@@ -13599,7 +13739,7 @@
           </a:ln>
         </p:spPr>
         <p:txBody>
-          <a:bodyPr anchorCtr="0" anchor="t" bIns="34275" lIns="68575" spcFirstLastPara="1" rIns="68575" wrap="square" tIns="34275">
+          <a:bodyPr anchorCtr="0" anchor="t" bIns="54864" lIns="73152" spcFirstLastPara="1" rIns="73152" wrap="square" tIns="54864">
             <a:noAutofit/>
           </a:bodyPr>
           <a:lstStyle/>
@@ -13612,7 +13752,7 @@
                 <a:spcPts val="0"/>
               </a:spcBef>
               <a:spcAft>
-                <a:spcPts val="0"/>
+                <a:spcPts val="200"/>
               </a:spcAft>
               <a:buClr>
                 <a:schemeClr val="dk1"/>
@@ -13620,15 +13760,15 @@
               <a:buSzPts val="1200"/>
               <a:buFont typeface="Noto Sans Symbols"/>
               <a:buNone/>
-              <a:defRPr sz="1050" b="1">
-                <a:solidFill>
-                  <a:srgbClr val="064E3B"/>
-                </a:solidFill>
-                <a:latin typeface="Arial"/>
-              </a:defRPr>
             </a:pPr>
             <a:r>
-              <a:t>▶ Core Software Frameworks &amp; Runtimes:</a:t>
+              <a:rPr sz="1100" b="1">
+                <a:solidFill>
+                  <a:srgbClr val="B45309"/>
+                </a:solidFill>
+                <a:latin typeface="Calibri"/>
+              </a:rPr>
+              <a:t>▶ Software Frameworks &amp; Libraries:</a:t>
             </a:r>
             <a:endParaRPr b="0" i="0" sz="1400" u="none" cap="none" strike="noStrike">
               <a:solidFill>
@@ -13642,158 +13782,91 @@
           </a:p>
           <a:p>
             <a:pPr>
-              <a:defRPr sz="980" b="0">
-                <a:solidFill>
-                  <a:srgbClr val="0F172A"/>
-                </a:solidFill>
-                <a:latin typeface="Arial"/>
-              </a:defRPr>
+              <a:lnSpc>
+                <a:spcPct val="110000"/>
+              </a:lnSpc>
+              <a:spcAft>
+                <a:spcPts val="700"/>
+              </a:spcAft>
             </a:pPr>
             <a:r>
-              <a:t>• Node.js 20+ runtime &amp; Next.js 16.3 / React 19 web framework</a:t>
+              <a:rPr sz="1040" b="0">
+                <a:solidFill>
+                  <a:srgbClr val="1E293B"/>
+                </a:solidFill>
+                <a:latin typeface="Calibri"/>
+              </a:rPr>
+              <a:t>• Node.js 20+, Next.js 16.3 / React 19, Prisma 5.22 with SQLite database, Tailwind CSS v4, Lucide React icons.</a:t>
             </a:r>
           </a:p>
           <a:p>
             <a:pPr>
-              <a:defRPr sz="980" b="0">
-                <a:solidFill>
-                  <a:srgbClr val="0F172A"/>
-                </a:solidFill>
-                <a:latin typeface="Arial"/>
-              </a:defRPr>
+              <a:spcAft>
+                <a:spcPts val="200"/>
+              </a:spcAft>
             </a:pPr>
             <a:r>
-              <a:t>• Prisma 5.22 ORM with SQLite relational database</a:t>
+              <a:rPr sz="1100" b="1">
+                <a:solidFill>
+                  <a:srgbClr val="B45309"/>
+                </a:solidFill>
+                <a:latin typeface="Calibri"/>
+              </a:rPr>
+              <a:t>▶ Cloud &amp; Web APIs:</a:t>
             </a:r>
           </a:p>
           <a:p>
             <a:pPr>
-              <a:defRPr sz="980" b="0">
-                <a:solidFill>
-                  <a:srgbClr val="0F172A"/>
-                </a:solidFill>
-                <a:latin typeface="Arial"/>
-              </a:defRPr>
+              <a:lnSpc>
+                <a:spcPct val="110000"/>
+              </a:lnSpc>
+              <a:spcAft>
+                <a:spcPts val="700"/>
+              </a:spcAft>
             </a:pPr>
             <a:r>
-              <a:t>• Tailwind CSS v4, Lucide React icons, Canvas2D HTML5 API</a:t>
+              <a:rPr sz="1040" b="0">
+                <a:solidFill>
+                  <a:srgbClr val="1E293B"/>
+                </a:solidFill>
+                <a:latin typeface="Calibri"/>
+              </a:rPr>
+              <a:t>• Google Gemini API (qualitative advisory &amp; SWOT), Web Speech API (voice recognition), OpenStreetMap / Carto (catchment tile layers).</a:t>
             </a:r>
           </a:p>
           <a:p>
             <a:pPr>
-              <a:defRPr sz="1050" b="1">
-                <a:solidFill>
-                  <a:srgbClr val="064E3B"/>
-                </a:solidFill>
-                <a:latin typeface="Arial"/>
-              </a:defRPr>
+              <a:spcAft>
+                <a:spcPts val="200"/>
+              </a:spcAft>
             </a:pPr>
             <a:r>
-              <a:t>▶ External Services &amp; Web APIs:</a:t>
+              <a:rPr sz="1100" b="1">
+                <a:solidFill>
+                  <a:srgbClr val="B45309"/>
+                </a:solidFill>
+                <a:latin typeface="Calibri"/>
+              </a:rPr>
+              <a:t>▶ Cloud Infrastructure &amp; DevOps:</a:t>
             </a:r>
           </a:p>
           <a:p>
             <a:pPr>
-              <a:defRPr sz="980" b="0">
-                <a:solidFill>
-                  <a:srgbClr val="0F172A"/>
-                </a:solidFill>
-                <a:latin typeface="Arial"/>
-              </a:defRPr>
+              <a:lnSpc>
+                <a:spcPct val="110000"/>
+              </a:lnSpc>
+              <a:spcAft>
+                <a:spcPts val="700"/>
+              </a:spcAft>
             </a:pPr>
             <a:r>
-              <a:t>• Google Gemini API (Qualitative advisory &amp; localized SWOT)</a:t>
-            </a:r>
-          </a:p>
-          <a:p>
-            <a:pPr>
-              <a:defRPr sz="980" b="0">
-                <a:solidFill>
-                  <a:srgbClr val="0F172A"/>
-                </a:solidFill>
-                <a:latin typeface="Arial"/>
-              </a:defRPr>
-            </a:pPr>
-            <a:r>
-              <a:t>• OpenStreetMap / Carto CDN (Tile layer catchment rendering)</a:t>
-            </a:r>
-          </a:p>
-          <a:p>
-            <a:pPr>
-              <a:defRPr sz="980" b="0">
-                <a:solidFill>
-                  <a:srgbClr val="0F172A"/>
-                </a:solidFill>
-                <a:latin typeface="Arial"/>
-              </a:defRPr>
-            </a:pPr>
-            <a:r>
-              <a:t>• Web Speech API (Voice recognition &amp; speech synthesis)</a:t>
-            </a:r>
-          </a:p>
-          <a:p>
-            <a:pPr>
-              <a:defRPr sz="1050" b="1">
-                <a:solidFill>
-                  <a:srgbClr val="B45309"/>
-                </a:solidFill>
-                <a:latin typeface="Arial"/>
-              </a:defRPr>
-            </a:pPr>
-            <a:r>
-              <a:t>▶ Cloud Infrastructure &amp; DevOps Tooling:</a:t>
-            </a:r>
-          </a:p>
-          <a:p>
-            <a:pPr>
-              <a:defRPr sz="980" b="0">
-                <a:solidFill>
-                  <a:srgbClr val="0F172A"/>
-                </a:solidFill>
-                <a:latin typeface="Arial"/>
-              </a:defRPr>
-            </a:pPr>
-            <a:r>
-              <a:t>• AWS EC2 Ubuntu 24.04 (t3.medium, ap-south-1b) with Elastic IP 13.126.176.46</a:t>
-            </a:r>
-          </a:p>
-          <a:p>
-            <a:pPr>
-              <a:defRPr sz="980" b="0">
-                <a:solidFill>
-                  <a:srgbClr val="0F172A"/>
-                </a:solidFill>
-                <a:latin typeface="Arial"/>
-              </a:defRPr>
-            </a:pPr>
-            <a:r>
-              <a:t>• Docker &amp; Docker Compose multi-stage containerization</a:t>
-            </a:r>
-          </a:p>
-          <a:p>
-            <a:pPr>
-              <a:defRPr sz="980" b="0">
-                <a:solidFill>
-                  <a:srgbClr val="0F172A"/>
-                </a:solidFill>
-                <a:latin typeface="Arial"/>
-              </a:defRPr>
-            </a:pPr>
-            <a:r>
-              <a:t>• Caddy Web Server (Automated Let's Encrypt TLS issuance)</a:t>
-            </a:r>
-          </a:p>
-          <a:p>
-            <a:pPr>
-              <a:defRPr sz="980" b="0">
-                <a:solidFill>
-                  <a:srgbClr val="0F172A"/>
-                </a:solidFill>
-                <a:latin typeface="Arial"/>
-              </a:defRPr>
-            </a:pPr>
-            <a:r>
-              <a:t>• Terraform 1.5+ for declarative cloud provisioning</a:t>
+              <a:rPr sz="1040" b="0">
+                <a:solidFill>
+                  <a:srgbClr val="1E293B"/>
+                </a:solidFill>
+                <a:latin typeface="Calibri"/>
+              </a:rPr>
+              <a:t>• AWS EC2 Ubuntu 24.04 (t3.medium) with Docker containerization, Caddy Web Server (automated HTTPS / TLS), Terraform IaC automation.</a:t>
             </a:r>
           </a:p>
         </p:txBody>
@@ -14057,8 +14130,8 @@
         </p:nvSpPr>
         <p:spPr>
           <a:xfrm>
-            <a:off x="640080" y="1280160"/>
-            <a:ext cx="3840480" cy="365760"/>
+            <a:off x="594360" y="1188720"/>
+            <a:ext cx="3977639" cy="320040"/>
           </a:xfrm>
           <a:prstGeom prst="rect">
             <a:avLst/>
@@ -14069,7 +14142,7 @@
           </a:ln>
         </p:spPr>
         <p:txBody>
-          <a:bodyPr anchorCtr="0" anchor="b" bIns="34275" lIns="68575" spcFirstLastPara="1" rIns="68575" wrap="square" tIns="34275">
+          <a:bodyPr anchorCtr="0" anchor="b" bIns="54864" lIns="73152" spcFirstLastPara="1" rIns="73152" wrap="square" tIns="54864">
             <a:normAutofit/>
           </a:bodyPr>
           <a:lstStyle/>
@@ -14087,6 +14160,15 @@
               <a:buSzPts val="1800"/>
               <a:buNone/>
             </a:pPr>
+            <a:r>
+              <a:rPr sz="1300" b="1">
+                <a:solidFill>
+                  <a:srgbClr val="064E3B"/>
+                </a:solidFill>
+                <a:latin typeface="Calibri"/>
+              </a:rPr>
+              <a:t>Uniqueness of your Idea</a:t>
+            </a:r>
             <a:endParaRPr b="0" sz="1500">
               <a:solidFill>
                 <a:schemeClr val="dk1"/>
@@ -14097,31 +14179,20 @@
               <a:sym typeface="Franklin Gothic"/>
             </a:endParaRPr>
           </a:p>
-          <a:p>
-            <a:r>
-              <a:rPr sz="1250" b="1">
-                <a:solidFill>
-                  <a:srgbClr val="1E3A8A"/>
-                </a:solidFill>
-                <a:latin typeface="Calibri"/>
-              </a:rPr>
-              <a:t>Uniqueness of your Idea</a:t>
-            </a:r>
-          </a:p>
         </p:txBody>
       </p:sp>
       <p:sp>
         <p:nvSpPr>
-          <p:cNvPr id="109" name="Google Shape;109;p4"/>
+          <p:cNvPr id="108" name="Google Shape;108;p4"/>
           <p:cNvSpPr txBox="1"/>
           <p:nvPr>
-            <p:ph idx="4" type="body"/>
+            <p:ph idx="3" type="body"/>
           </p:nvPr>
         </p:nvSpPr>
         <p:spPr>
           <a:xfrm>
-            <a:off x="4629150" y="1878806"/>
-            <a:ext cx="3887400" cy="2763300"/>
+            <a:off x="4709160" y="1188720"/>
+            <a:ext cx="3977639" cy="320040"/>
           </a:xfrm>
           <a:prstGeom prst="rect">
             <a:avLst/>
@@ -14132,7 +14203,7 @@
           </a:ln>
         </p:spPr>
         <p:txBody>
-          <a:bodyPr anchorCtr="0" anchor="t" bIns="34275" lIns="68575" spcFirstLastPara="1" rIns="68575" wrap="square" tIns="34275">
+          <a:bodyPr anchorCtr="0" anchor="b" bIns="54864" lIns="73152" spcFirstLastPara="1" rIns="73152" wrap="square" tIns="54864">
             <a:normAutofit/>
           </a:bodyPr>
           <a:lstStyle/>
@@ -14147,13 +14218,27 @@
               <a:spcAft>
                 <a:spcPts val="0"/>
               </a:spcAft>
-              <a:buSzPts val="1400"/>
+              <a:buSzPts val="1800"/>
               <a:buNone/>
             </a:pPr>
             <a:r>
-              <a:t/>
+              <a:rPr sz="1300" b="1">
+                <a:solidFill>
+                  <a:srgbClr val="064E3B"/>
+                </a:solidFill>
+                <a:latin typeface="Calibri"/>
+              </a:rPr>
+              <a:t>Future Scope and Impact</a:t>
             </a:r>
-            <a:endParaRPr/>
+            <a:endParaRPr sz="1500">
+              <a:solidFill>
+                <a:schemeClr val="dk1"/>
+              </a:solidFill>
+              <a:latin typeface="Franklin Gothic"/>
+              <a:ea typeface="Franklin Gothic"/>
+              <a:cs typeface="Franklin Gothic"/>
+              <a:sym typeface="Franklin Gothic"/>
+            </a:endParaRPr>
           </a:p>
         </p:txBody>
       </p:sp>
@@ -14219,8 +14304,8 @@
         </p:nvSpPr>
         <p:spPr>
           <a:xfrm>
-            <a:off x="640080" y="1691640"/>
-            <a:ext cx="3840480" cy="3154680"/>
+            <a:off x="594360" y="1554480"/>
+            <a:ext cx="3977639" cy="3337560"/>
           </a:xfrm>
           <a:prstGeom prst="rect">
             <a:avLst/>
@@ -14228,99 +14313,176 @@
           <a:noFill/>
         </p:spPr>
         <p:txBody>
-          <a:bodyPr wrap="square">
+          <a:bodyPr wrap="square" lIns="73152" rIns="73152" tIns="54864" bIns="54864">
             <a:spAutoFit/>
           </a:bodyPr>
           <a:lstStyle/>
           <a:p>
             <a:pPr>
-              <a:defRPr sz="980" b="0">
-                <a:solidFill>
-                  <a:srgbClr val="0F172A"/>
-                </a:solidFill>
-                <a:latin typeface="Arial"/>
-              </a:defRPr>
+              <a:lnSpc>
+                <a:spcPct val="108000"/>
+              </a:lnSpc>
+              <a:spcAft>
+                <a:spcPts val="500"/>
+              </a:spcAft>
             </a:pPr>
             <a:r>
-              <a:t>• Decoupled Deterministic Financial Engine: Unlike naive LLM wrappers that hallucinate loan math, debt sizing and moratorium schedules are computed using 100% verified statutory formulas.</a:t>
+              <a:rPr sz="1060" b="1">
+                <a:solidFill>
+                  <a:srgbClr val="0F172A"/>
+                </a:solidFill>
+                <a:latin typeface="Calibri"/>
+              </a:rPr>
+              <a:t>• Deterministic Financial Math: </a:t>
+            </a:r>
+            <a:r>
+              <a:rPr sz="1019" b="0">
+                <a:solidFill>
+                  <a:srgbClr val="1E293B"/>
+                </a:solidFill>
+                <a:latin typeface="Calibri"/>
+              </a:rPr>
+              <a:t>Zero LLM hallucinations—debt sizing and moratoriums follow 100% statutory formulas.</a:t>
             </a:r>
           </a:p>
           <a:p>
             <a:pPr>
-              <a:defRPr sz="980" b="0">
-                <a:solidFill>
-                  <a:srgbClr val="0F172A"/>
-                </a:solidFill>
-                <a:latin typeface="Arial"/>
-              </a:defRPr>
+              <a:lnSpc>
+                <a:spcPct val="108000"/>
+              </a:lnSpc>
+              <a:spcAft>
+                <a:spcPts val="500"/>
+              </a:spcAft>
             </a:pPr>
             <a:r>
-              <a:t>• Automated Statutory Scheme Routing: Intelligently routes projects &lt;= ₹1.40L to Micro Finance (6.5% p.a., 3-mo grace) and projects &gt; ₹1.40L to Term Loan (8.0% p.a., 6-mo grace).</a:t>
+              <a:rPr sz="1060" b="1">
+                <a:solidFill>
+                  <a:srgbClr val="0F172A"/>
+                </a:solidFill>
+                <a:latin typeface="Calibri"/>
+              </a:rPr>
+              <a:t>• Automated Scheme Routing: </a:t>
+            </a:r>
+            <a:r>
+              <a:rPr sz="1019" b="0">
+                <a:solidFill>
+                  <a:srgbClr val="1E293B"/>
+                </a:solidFill>
+                <a:latin typeface="Calibri"/>
+              </a:rPr>
+              <a:t>Intelligently routes projects &lt;= ₹1.40L to Micro Finance (6.5%) and &gt; ₹1.40L to Term Loan (8.0%).</a:t>
             </a:r>
           </a:p>
           <a:p>
             <a:pPr>
-              <a:defRPr sz="980" b="0">
-                <a:solidFill>
-                  <a:srgbClr val="0F172A"/>
-                </a:solidFill>
-                <a:latin typeface="Arial"/>
-              </a:defRPr>
+              <a:lnSpc>
+                <a:spcPct val="108000"/>
+              </a:lnSpc>
+              <a:spcAft>
+                <a:spcPts val="500"/>
+              </a:spcAft>
             </a:pPr>
             <a:r>
-              <a:t>• Hyper-Local Concentric Catchment (5 &amp; 10 km): Granular spatial demographic density, trade-adaptive POIs, and competitor density.</a:t>
+              <a:rPr sz="1060" b="1">
+                <a:solidFill>
+                  <a:srgbClr val="0F172A"/>
+                </a:solidFill>
+                <a:latin typeface="Calibri"/>
+              </a:rPr>
+              <a:t>• Hyper-Local 5 &amp; 10 km Catchment: </a:t>
+            </a:r>
+            <a:r>
+              <a:rPr sz="1019" b="0">
+                <a:solidFill>
+                  <a:srgbClr val="1E293B"/>
+                </a:solidFill>
+                <a:latin typeface="Calibri"/>
+              </a:rPr>
+              <a:t>Granular spatial demographics, competitor density, and trade-adaptive POIs.</a:t>
             </a:r>
           </a:p>
           <a:p>
             <a:pPr>
-              <a:defRPr sz="980" b="0">
-                <a:solidFill>
-                  <a:srgbClr val="0F172A"/>
-                </a:solidFill>
-                <a:latin typeface="Arial"/>
-              </a:defRPr>
+              <a:lnSpc>
+                <a:spcPct val="108000"/>
+              </a:lnSpc>
+              <a:spcAft>
+                <a:spcPts val="500"/>
+              </a:spcAft>
             </a:pPr>
             <a:r>
-              <a:t>• Multi-Enterprise Portfolio Engine: Solves real-world multi-business management with persistent Dossier IDs and reactive cross-app switching.</a:t>
+              <a:rPr sz="1060" b="1">
+                <a:solidFill>
+                  <a:srgbClr val="0F172A"/>
+                </a:solidFill>
+                <a:latin typeface="Calibri"/>
+              </a:rPr>
+              <a:t>• Multi-Enterprise Portfolio: </a:t>
+            </a:r>
+            <a:r>
+              <a:rPr sz="1019" b="0">
+                <a:solidFill>
+                  <a:srgbClr val="1E293B"/>
+                </a:solidFill>
+                <a:latin typeface="Calibri"/>
+              </a:rPr>
+              <a:t>Solves real-world multi-business management with persistent Dossier IDs and reactive switching.</a:t>
             </a:r>
           </a:p>
           <a:p>
             <a:pPr>
-              <a:defRPr sz="980" b="0">
-                <a:solidFill>
-                  <a:srgbClr val="0F172A"/>
-                </a:solidFill>
-                <a:latin typeface="Arial"/>
-              </a:defRPr>
+              <a:lnSpc>
+                <a:spcPct val="108000"/>
+              </a:lnSpc>
+              <a:spcAft>
+                <a:spcPts val="500"/>
+              </a:spcAft>
             </a:pPr>
             <a:r>
-              <a:t>• 1-Click Zero-Crash PDF Export: Proprietary Canvas2D color proxy converts modern lab/oklch color spaces, downloading clean PDFs in &lt;1.5s with zero print dialogs.</a:t>
+              <a:rPr sz="1060" b="1">
+                <a:solidFill>
+                  <a:srgbClr val="0F172A"/>
+                </a:solidFill>
+                <a:latin typeface="Calibri"/>
+              </a:rPr>
+              <a:t>• 1-Click Zero-Crash PDF Export: </a:t>
+            </a:r>
+            <a:r>
+              <a:rPr sz="1019" b="0">
+                <a:solidFill>
+                  <a:srgbClr val="1E293B"/>
+                </a:solidFill>
+                <a:latin typeface="Calibri"/>
+              </a:rPr>
+              <a:t>Canvas2D color proxy converts modern lab/oklch colors in &lt;1.5s with zero print dialogs.</a:t>
             </a:r>
           </a:p>
           <a:p>
             <a:pPr>
-              <a:defRPr sz="980" b="0">
-                <a:solidFill>
-                  <a:srgbClr val="0F172A"/>
-                </a:solidFill>
-                <a:latin typeface="Arial"/>
-              </a:defRPr>
+              <a:lnSpc>
+                <a:spcPct val="108000"/>
+              </a:lnSpc>
+              <a:spcAft>
+                <a:spcPts val="500"/>
+              </a:spcAft>
             </a:pPr>
             <a:r>
-              <a:t>• Trilingual Accessibility with Guardrails: Native English, Hindi, and Gujarati with strict semantic guardrails preventing off-topic abuse.</a:t>
+              <a:rPr sz="1060" b="1">
+                <a:solidFill>
+                  <a:srgbClr val="0F172A"/>
+                </a:solidFill>
+                <a:latin typeface="Calibri"/>
+              </a:rPr>
+              <a:t>• Trilingual Guardrailed AI: </a:t>
             </a:r>
-          </a:p>
-          <a:p>
-            <a:pPr>
-              <a:defRPr sz="980" b="0">
-                <a:solidFill>
-                  <a:srgbClr val="0F172A"/>
-                </a:solidFill>
-                <a:latin typeface="Arial"/>
-              </a:defRPr>
-            </a:pPr>
             <a:r>
-              <a:t>• Dual-Cloud Production Resilience: Live on both AWS EC2 (Docker + Caddy) and Vercel Edge.</a:t>
+              <a:rPr sz="1019" b="0">
+                <a:solidFill>
+                  <a:srgbClr val="1E293B"/>
+                </a:solidFill>
+                <a:latin typeface="Calibri"/>
+              </a:rPr>
+              <a:t>Native English, Hindi, and Gujarati with strict rejection of off-topic prompts.</a:t>
             </a:r>
           </a:p>
         </p:txBody>
@@ -14333,8 +14495,8 @@
         </p:nvSpPr>
         <p:spPr>
           <a:xfrm>
-            <a:off x="4663440" y="1691640"/>
-            <a:ext cx="3840480" cy="3154680"/>
+            <a:off x="4709160" y="1554480"/>
+            <a:ext cx="3977639" cy="3337560"/>
           </a:xfrm>
           <a:prstGeom prst="rect">
             <a:avLst/>
@@ -14342,125 +14504,208 @@
           <a:noFill/>
         </p:spPr>
         <p:txBody>
-          <a:bodyPr wrap="square">
+          <a:bodyPr wrap="square" lIns="73152" rIns="73152" tIns="54864" bIns="54864">
             <a:spAutoFit/>
           </a:bodyPr>
           <a:lstStyle/>
           <a:p>
             <a:pPr>
-              <a:defRPr sz="1050" b="1">
-                <a:solidFill>
-                  <a:srgbClr val="064E3B"/>
-                </a:solidFill>
-                <a:latin typeface="Arial"/>
-              </a:defRPr>
+              <a:spcAft>
+                <a:spcPts val="200"/>
+              </a:spcAft>
             </a:pPr>
             <a:r>
+              <a:rPr sz="1100" b="1">
+                <a:solidFill>
+                  <a:srgbClr val="B45309"/>
+                </a:solidFill>
+                <a:latin typeface="Calibri"/>
+              </a:rPr>
               <a:t>▶ Measurable Socio-Economic Impact:</a:t>
             </a:r>
           </a:p>
           <a:p>
             <a:pPr>
-              <a:defRPr sz="980" b="0">
-                <a:solidFill>
-                  <a:srgbClr val="0F172A"/>
-                </a:solidFill>
-                <a:latin typeface="Arial"/>
-              </a:defRPr>
+              <a:lnSpc>
+                <a:spcPct val="108000"/>
+              </a:lnSpc>
+              <a:spcAft>
+                <a:spcPts val="300"/>
+              </a:spcAft>
             </a:pPr>
             <a:r>
-              <a:t>• Reduces 40%+ early enterprise mortality by replacing hearsay with data-driven demand validation.</a:t>
+              <a:rPr sz="1040" b="1">
+                <a:solidFill>
+                  <a:srgbClr val="0F172A"/>
+                </a:solidFill>
+                <a:latin typeface="Calibri"/>
+              </a:rPr>
+              <a:t>• Reduces 40%+ early failure rate </a:t>
+            </a:r>
+            <a:r>
+              <a:rPr sz="1019" b="0">
+                <a:solidFill>
+                  <a:srgbClr val="1E293B"/>
+                </a:solidFill>
+                <a:latin typeface="Calibri"/>
+              </a:rPr>
+              <a:t>through empirical local demand validation.</a:t>
             </a:r>
           </a:p>
           <a:p>
             <a:pPr>
-              <a:defRPr sz="980" b="0">
-                <a:solidFill>
-                  <a:srgbClr val="0F172A"/>
-                </a:solidFill>
-                <a:latin typeface="Arial"/>
-              </a:defRPr>
+              <a:lnSpc>
+                <a:spcPct val="108000"/>
+              </a:lnSpc>
+              <a:spcAft>
+                <a:spcPts val="300"/>
+              </a:spcAft>
             </a:pPr>
             <a:r>
-              <a:t>• Cuts bank appraisal preparation time from 4–6 weeks to under 90 seconds.</a:t>
+              <a:rPr sz="1040" b="1">
+                <a:solidFill>
+                  <a:srgbClr val="0F172A"/>
+                </a:solidFill>
+                <a:latin typeface="Calibri"/>
+              </a:rPr>
+              <a:t>• Cuts bank appraisal preparation time </a:t>
+            </a:r>
+            <a:r>
+              <a:rPr sz="1019" b="0">
+                <a:solidFill>
+                  <a:srgbClr val="1E293B"/>
+                </a:solidFill>
+                <a:latin typeface="Calibri"/>
+              </a:rPr>
+              <a:t>from 4–6 weeks to under 90 seconds.</a:t>
             </a:r>
           </a:p>
           <a:p>
             <a:pPr>
-              <a:defRPr sz="980" b="0">
-                <a:solidFill>
-                  <a:srgbClr val="0F172A"/>
-                </a:solidFill>
-                <a:latin typeface="Arial"/>
-              </a:defRPr>
+              <a:lnSpc>
+                <a:spcPct val="108000"/>
+              </a:lnSpc>
+              <a:spcAft>
+                <a:spcPts val="300"/>
+              </a:spcAft>
             </a:pPr>
             <a:r>
-              <a:t>• Unlocks statutory concessional debt for marginalized rural founders, replacing predatory moneylenders (24%–36% interest).</a:t>
+              <a:rPr sz="1040" b="1">
+                <a:solidFill>
+                  <a:srgbClr val="0F172A"/>
+                </a:solidFill>
+                <a:latin typeface="Calibri"/>
+              </a:rPr>
+              <a:t>• Unlocks statutory concessional debt, </a:t>
+            </a:r>
+            <a:r>
+              <a:rPr sz="1019" b="0">
+                <a:solidFill>
+                  <a:srgbClr val="1E293B"/>
+                </a:solidFill>
+                <a:latin typeface="Calibri"/>
+              </a:rPr>
+              <a:t>replacing predatory moneylenders (24%–36% interest).</a:t>
             </a:r>
           </a:p>
           <a:p>
             <a:pPr>
-              <a:defRPr sz="1050" b="1">
-                <a:solidFill>
-                  <a:srgbClr val="B45309"/>
-                </a:solidFill>
-                <a:latin typeface="Arial"/>
-              </a:defRPr>
+              <a:spcAft>
+                <a:spcPts val="200"/>
+              </a:spcAft>
             </a:pPr>
             <a:r>
-              <a:t>▶ Future Engineering Scope &amp; Roadmap:</a:t>
+              <a:rPr sz="1100" b="1">
+                <a:solidFill>
+                  <a:srgbClr val="B45309"/>
+                </a:solidFill>
+                <a:latin typeface="Calibri"/>
+              </a:rPr>
+              <a:t>▶ Future Roadmap &amp; Scaling:</a:t>
             </a:r>
           </a:p>
           <a:p>
             <a:pPr>
-              <a:defRPr sz="980" b="0">
-                <a:solidFill>
-                  <a:srgbClr val="0F172A"/>
-                </a:solidFill>
-                <a:latin typeface="Arial"/>
-              </a:defRPr>
+              <a:lnSpc>
+                <a:spcPct val="108000"/>
+              </a:lnSpc>
+              <a:spcAft>
+                <a:spcPts val="300"/>
+              </a:spcAft>
             </a:pPr>
             <a:r>
-              <a:t>• SCA &amp; JanSamarth Portal API: Direct automated loan application dispatch to State Channelizing Agencies and RRBs.</a:t>
+              <a:rPr sz="1040" b="1">
+                <a:solidFill>
+                  <a:srgbClr val="0F172A"/>
+                </a:solidFill>
+                <a:latin typeface="Calibri"/>
+              </a:rPr>
+              <a:t>• Bank &amp; SCA Portals: </a:t>
+            </a:r>
+            <a:r>
+              <a:rPr sz="1019" b="0">
+                <a:solidFill>
+                  <a:srgbClr val="1E293B"/>
+                </a:solidFill>
+                <a:latin typeface="Calibri"/>
+              </a:rPr>
+              <a:t>Direct API integration with JanSamarth and State Channelizing Agencies.</a:t>
             </a:r>
           </a:p>
           <a:p>
             <a:pPr>
-              <a:defRPr sz="980" b="0">
-                <a:solidFill>
-                  <a:srgbClr val="0F172A"/>
-                </a:solidFill>
-                <a:latin typeface="Arial"/>
-              </a:defRPr>
+              <a:lnSpc>
+                <a:spcPct val="108000"/>
+              </a:lnSpc>
+              <a:spcAft>
+                <a:spcPts val="300"/>
+              </a:spcAft>
             </a:pPr>
             <a:r>
-              <a:t>• Live Mandi &amp; APMC Feeds: Real-time price tracking via e-NAM APIs for hyper-local commodity arbitrage.</a:t>
+              <a:rPr sz="1040" b="1">
+                <a:solidFill>
+                  <a:srgbClr val="0F172A"/>
+                </a:solidFill>
+                <a:latin typeface="Calibri"/>
+              </a:rPr>
+              <a:t>• Live e-NAM Feeds: </a:t>
+            </a:r>
+            <a:r>
+              <a:rPr sz="1019" b="0">
+                <a:solidFill>
+                  <a:srgbClr val="1E293B"/>
+                </a:solidFill>
+                <a:latin typeface="Calibri"/>
+              </a:rPr>
+              <a:t>Real-time APMC mandi commodity spot price tracking.</a:t>
             </a:r>
           </a:p>
           <a:p>
             <a:pPr>
-              <a:defRPr sz="980" b="0">
-                <a:solidFill>
-                  <a:srgbClr val="0F172A"/>
-                </a:solidFill>
-                <a:latin typeface="Arial"/>
-              </a:defRPr>
+              <a:lnSpc>
+                <a:spcPct val="108000"/>
+              </a:lnSpc>
+              <a:spcAft>
+                <a:spcPts val="300"/>
+              </a:spcAft>
             </a:pPr>
             <a:r>
-              <a:t>• Offline Edge AI: Local on-device LLM execution (Gemma 2B / WebLLM) for zero-connectivity deep rural operation.</a:t>
+              <a:rPr sz="1040" b="1">
+                <a:solidFill>
+                  <a:srgbClr val="0F172A"/>
+                </a:solidFill>
+                <a:latin typeface="Calibri"/>
+              </a:rPr>
+              <a:t>• Offline Edge AI: </a:t>
             </a:r>
-          </a:p>
-          <a:p>
-            <a:pPr>
-              <a:defRPr sz="980" b="0">
-                <a:solidFill>
-                  <a:srgbClr val="0F172A"/>
-                </a:solidFill>
-                <a:latin typeface="Arial"/>
-              </a:defRPr>
-            </a:pPr>
             <a:r>
-              <a:t>• SHG &amp; Cooperative Multi-Tenant Mode: Sizing pooled capital for Self-Help Groups and Women Milk Societies.</a:t>
+              <a:rPr sz="1019" b="0">
+                <a:solidFill>
+                  <a:srgbClr val="1E293B"/>
+                </a:solidFill>
+                <a:latin typeface="Calibri"/>
+              </a:rPr>
+              <a:t>On-device localized inference for remote tribal clusters with zero internet.</a:t>
             </a:r>
           </a:p>
         </p:txBody>
@@ -14795,18 +15040,38 @@
               <a:buSzPct val="120000"/>
               <a:buNone/>
             </a:pPr>
+            <a:r>
+              <a:rPr b="1" lang="en-GB" sz="3000">
+                <a:solidFill>
+                  <a:schemeClr val="dk1"/>
+                </a:solidFill>
+              </a:rPr>
+              <a:t>Additional Details(</a:t>
+            </a:r>
+            <a:r>
+              <a:rPr b="1" lang="en-GB" sz="1800">
+                <a:solidFill>
+                  <a:schemeClr val="dk1"/>
+                </a:solidFill>
+              </a:rPr>
+              <a:t>Kee</a:t>
+            </a:r>
+            <a:r>
+              <a:rPr b="1" lang="en-GB" sz="1800"/>
+              <a:t>p the content limited to</a:t>
+            </a:r>
+            <a:br>
+              <a:rPr b="1" lang="en-GB" sz="1800"/>
+            </a:br>
+            <a:r>
+              <a:rPr b="1" lang="en-GB" sz="1800"/>
+              <a:t>t</a:t>
+            </a:r>
+            <a:r>
+              <a:rPr b="1" lang="en-GB" sz="1800"/>
+              <a:t>his slide only)</a:t>
+            </a:r>
             <a:endParaRPr sz="1800"/>
-          </a:p>
-          <a:p>
-            <a:r>
-              <a:rPr sz="2800" b="1">
-                <a:solidFill>
-                  <a:srgbClr val="0F172A"/>
-                </a:solidFill>
-                <a:latin typeface="Calibri"/>
-              </a:rPr>
-              <a:t>Additional Details</a:t>
-            </a:r>
           </a:p>
         </p:txBody>
       </p:sp>
@@ -14818,8 +15083,8 @@
         </p:nvSpPr>
         <p:spPr>
           <a:xfrm>
-            <a:off x="640080" y="1280160"/>
-            <a:ext cx="3840480" cy="3566160"/>
+            <a:off x="594360" y="1234440"/>
+            <a:ext cx="3977639" cy="3657600"/>
           </a:xfrm>
           <a:prstGeom prst="rect">
             <a:avLst/>
@@ -14827,86 +15092,136 @@
           <a:noFill/>
         </p:spPr>
         <p:txBody>
-          <a:bodyPr wrap="square">
+          <a:bodyPr wrap="square" lIns="73152" rIns="73152" tIns="54864" bIns="54864">
             <a:spAutoFit/>
           </a:bodyPr>
           <a:lstStyle/>
           <a:p>
             <a:pPr>
-              <a:defRPr sz="1100" b="1">
-                <a:solidFill>
-                  <a:srgbClr val="064E3B"/>
-                </a:solidFill>
-                <a:latin typeface="Arial"/>
-              </a:defRPr>
+              <a:spcAft>
+                <a:spcPts val="800"/>
+              </a:spcAft>
             </a:pPr>
             <a:r>
+              <a:rPr sz="1300" b="1">
+                <a:solidFill>
+                  <a:srgbClr val="064E3B"/>
+                </a:solidFill>
+                <a:latin typeface="Calibri"/>
+              </a:rPr>
               <a:t>1. Live Prototype &amp; Verification Highlights</a:t>
             </a:r>
           </a:p>
           <a:p>
             <a:pPr>
-              <a:defRPr sz="980" b="0">
-                <a:solidFill>
-                  <a:srgbClr val="0F172A"/>
-                </a:solidFill>
-                <a:latin typeface="Arial"/>
-              </a:defRPr>
+              <a:lnSpc>
+                <a:spcPct val="112000"/>
+              </a:lnSpc>
+              <a:spcAft>
+                <a:spcPts val="800"/>
+              </a:spcAft>
             </a:pPr>
             <a:r>
-              <a:t>• Dual-Cloud Production Endpoints: Live and verified with HTTP/2 200 OK on AWS EC2 (https://gramsaarthi-ai.chiragvasava.me) and Vercel Edge (https://gramsaarthi.chiragvasava.me).</a:t>
+              <a:rPr sz="1080" b="1">
+                <a:solidFill>
+                  <a:srgbClr val="0F172A"/>
+                </a:solidFill>
+                <a:latin typeface="Calibri"/>
+              </a:rPr>
+              <a:t>• 1-Click Demo Mode: </a:t>
+            </a:r>
+            <a:r>
+              <a:rPr sz="1050" b="0">
+                <a:solidFill>
+                  <a:srgbClr val="1E293B"/>
+                </a:solidFill>
+                <a:latin typeface="Calibri"/>
+              </a:rPr>
+              <a:t>Pre-configured credentials (demo@gramsaarthi.ai / demo123) allow evaluators to test all features instantly without sign-up friction.</a:t>
             </a:r>
           </a:p>
           <a:p>
             <a:pPr>
-              <a:defRPr sz="980" b="0">
-                <a:solidFill>
-                  <a:srgbClr val="0F172A"/>
-                </a:solidFill>
-                <a:latin typeface="Arial"/>
-              </a:defRPr>
+              <a:lnSpc>
+                <a:spcPct val="112000"/>
+              </a:lnSpc>
+              <a:spcAft>
+                <a:spcPts val="800"/>
+              </a:spcAft>
             </a:pPr>
             <a:r>
-              <a:t>• 1-Click Demo Evaluation Mode: Pre-configured credentials (demo@gramsaarthi.ai / demo123) allow evaluators to test all features instantly without registration friction.</a:t>
+              <a:rPr sz="1080" b="1">
+                <a:solidFill>
+                  <a:srgbClr val="0F172A"/>
+                </a:solidFill>
+                <a:latin typeface="Calibri"/>
+              </a:rPr>
+              <a:t>• Tested &amp; Working End-to-End: </a:t>
+            </a:r>
+            <a:r>
+              <a:rPr sz="1050" b="0">
+                <a:solidFill>
+                  <a:srgbClr val="1E293B"/>
+                </a:solidFill>
+                <a:latin typeface="Calibri"/>
+              </a:rPr>
+              <a:t>Every single user journey—Registration -&gt; Intake Wizard -&gt; Radial Map -&gt; Concessional Calculator -&gt; Trilingual Chat -&gt; Feasibility Report—empirically verified.</a:t>
             </a:r>
           </a:p>
           <a:p>
             <a:pPr>
-              <a:defRPr sz="980" b="0">
-                <a:solidFill>
-                  <a:srgbClr val="0F172A"/>
-                </a:solidFill>
-                <a:latin typeface="Arial"/>
-              </a:defRPr>
+              <a:lnSpc>
+                <a:spcPct val="112000"/>
+              </a:lnSpc>
+              <a:spcAft>
+                <a:spcPts val="800"/>
+              </a:spcAft>
             </a:pPr>
             <a:r>
-              <a:t>• Tested &amp; Working End-to-End: Every single user journey—Registration -&gt; Intake Wizard -&gt; Radial Map -&gt; Concessional Calculator -&gt; Trilingual Chat -&gt; Feasibility Report -&gt; Saved Portfolio—empirically verified.</a:t>
+              <a:rPr sz="1080" b="1">
+                <a:solidFill>
+                  <a:srgbClr val="0F172A"/>
+                </a:solidFill>
+                <a:latin typeface="Calibri"/>
+              </a:rPr>
+              <a:t>• Zero Hardcoded Data: </a:t>
+            </a:r>
+            <a:r>
+              <a:rPr sz="1050" b="0">
+                <a:solidFill>
+                  <a:srgbClr val="1E293B"/>
+                </a:solidFill>
+                <a:latin typeface="Calibri"/>
+              </a:rPr>
+              <a:t>Real-time dynamic scoring engine synthesizes all appraisal metrics on the fly based on user input.</a:t>
             </a:r>
           </a:p>
           <a:p>
             <a:pPr>
-              <a:defRPr sz="980" b="0">
-                <a:solidFill>
-                  <a:srgbClr val="0F172A"/>
-                </a:solidFill>
-                <a:latin typeface="Arial"/>
-              </a:defRPr>
+              <a:lnSpc>
+                <a:spcPct val="112000"/>
+              </a:lnSpc>
+              <a:spcAft>
+                <a:spcPts val="800"/>
+              </a:spcAft>
             </a:pPr>
             <a:r>
-              <a:t>• Zero Hardcoded Data: Live computeDynamicScore algorithm calculates real-time feasibility and debt structuring dynamically.</a:t>
+              <a:rPr sz="1080" b="1">
+                <a:solidFill>
+                  <a:srgbClr val="0F172A"/>
+                </a:solidFill>
+                <a:latin typeface="Calibri"/>
+              </a:rPr>
+              <a:t>• 1-Click Direct PDF: </a:t>
             </a:r>
-          </a:p>
-          <a:p>
-            <a:pPr>
-              <a:defRPr sz="980" b="0">
-                <a:solidFill>
-                  <a:srgbClr val="0F172A"/>
-                </a:solidFill>
-                <a:latin typeface="Arial"/>
-              </a:defRPr>
-            </a:pPr>
             <a:r>
-              <a:t>• 1-Click PDF Generation: Instant client-side download in &lt;1.5s via Canvas2D color proxy.</a:t>
+              <a:rPr sz="1050" b="0">
+                <a:solidFill>
+                  <a:srgbClr val="1E293B"/>
+                </a:solidFill>
+                <a:latin typeface="Calibri"/>
+              </a:rPr>
+              <a:t>Instant client-side download in &lt;1.5s via Canvas2D color proxy, eliminating browser print dialogs.</a:t>
             </a:r>
           </a:p>
         </p:txBody>
@@ -14919,8 +15234,8 @@
         </p:nvSpPr>
         <p:spPr>
           <a:xfrm>
-            <a:off x="4663440" y="1280160"/>
-            <a:ext cx="3840480" cy="3566160"/>
+            <a:off x="4709160" y="1234440"/>
+            <a:ext cx="3977639" cy="3657600"/>
           </a:xfrm>
           <a:prstGeom prst="rect">
             <a:avLst/>
@@ -14928,86 +15243,136 @@
           <a:noFill/>
         </p:spPr>
         <p:txBody>
-          <a:bodyPr wrap="square">
+          <a:bodyPr wrap="square" lIns="73152" rIns="73152" tIns="54864" bIns="54864">
             <a:spAutoFit/>
           </a:bodyPr>
           <a:lstStyle/>
           <a:p>
             <a:pPr>
-              <a:defRPr sz="1100" b="1">
-                <a:solidFill>
-                  <a:srgbClr val="064E3B"/>
-                </a:solidFill>
-                <a:latin typeface="Arial"/>
-              </a:defRPr>
+              <a:spcAft>
+                <a:spcPts val="800"/>
+              </a:spcAft>
             </a:pPr>
             <a:r>
-              <a:t>2. Alignment with P11 Problem Statement &amp; Screening</a:t>
+              <a:rPr sz="1300" b="1">
+                <a:solidFill>
+                  <a:srgbClr val="064E3B"/>
+                </a:solidFill>
+                <a:latin typeface="Calibri"/>
+              </a:rPr>
+              <a:t>2. Alignment with Problem Statement P11</a:t>
             </a:r>
           </a:p>
           <a:p>
             <a:pPr>
-              <a:defRPr sz="980" b="0">
-                <a:solidFill>
-                  <a:srgbClr val="0F172A"/>
-                </a:solidFill>
-                <a:latin typeface="Arial"/>
-              </a:defRPr>
+              <a:lnSpc>
+                <a:spcPct val="112000"/>
+              </a:lnSpc>
+              <a:spcAft>
+                <a:spcPts val="800"/>
+              </a:spcAft>
             </a:pPr>
             <a:r>
-              <a:t>• Strict Problem Statement Alignment: Directly solves P11 requirements: hyper-local business feasibility, statutory financial structuring, rural language accessibility, and bankable reporting.</a:t>
+              <a:rPr sz="1080" b="1">
+                <a:solidFill>
+                  <a:srgbClr val="0F172A"/>
+                </a:solidFill>
+                <a:latin typeface="Calibri"/>
+              </a:rPr>
+              <a:t>• Strict Problem Statement Alignment: </a:t>
+            </a:r>
+            <a:r>
+              <a:rPr sz="1050" b="0">
+                <a:solidFill>
+                  <a:srgbClr val="1E293B"/>
+                </a:solidFill>
+                <a:latin typeface="Calibri"/>
+              </a:rPr>
+              <a:t>Directly solves P11 requirements: hyper-local business feasibility, statutory financial structuring, rural language accessibility, and bankable reporting.</a:t>
             </a:r>
           </a:p>
           <a:p>
             <a:pPr>
-              <a:defRPr sz="980" b="0">
-                <a:solidFill>
-                  <a:srgbClr val="0F172A"/>
-                </a:solidFill>
-                <a:latin typeface="Arial"/>
-              </a:defRPr>
+              <a:lnSpc>
+                <a:spcPct val="112000"/>
+              </a:lnSpc>
+              <a:spcAft>
+                <a:spcPts val="800"/>
+              </a:spcAft>
             </a:pPr>
             <a:r>
-              <a:t>• Mathematical Auditability: Zero floating-point inaccuracies or LLM hallucinated debt figures; statutory credit guidelines strictly respected.</a:t>
+              <a:rPr sz="1080" b="1">
+                <a:solidFill>
+                  <a:srgbClr val="0F172A"/>
+                </a:solidFill>
+                <a:latin typeface="Calibri"/>
+              </a:rPr>
+              <a:t>• Mathematical Auditability: </a:t>
+            </a:r>
+            <a:r>
+              <a:rPr sz="1050" b="0">
+                <a:solidFill>
+                  <a:srgbClr val="1E293B"/>
+                </a:solidFill>
+                <a:latin typeface="Calibri"/>
+              </a:rPr>
+              <a:t>Zero floating-point inaccuracies or hallucinated loan math; statutory credit guidelines strictly respected.</a:t>
             </a:r>
           </a:p>
           <a:p>
             <a:pPr>
-              <a:defRPr sz="980" b="0">
-                <a:solidFill>
-                  <a:srgbClr val="0F172A"/>
-                </a:solidFill>
-                <a:latin typeface="Arial"/>
-              </a:defRPr>
+              <a:lnSpc>
+                <a:spcPct val="112000"/>
+              </a:lnSpc>
+              <a:spcAft>
+                <a:spcPts val="800"/>
+              </a:spcAft>
             </a:pPr>
             <a:r>
-              <a:t>• Complete Documentation Suite: Comprehensive documentation indexed in MD_Files/ (ARCHITECTURE.md, FEATURES.md, MANUAL_TEST_REPORT.md, DEMO_SCRIPT.md, TERRAFORM.md, DEPLOYMENT_CASE_STUDY.md).</a:t>
+              <a:rPr sz="1080" b="1">
+                <a:solidFill>
+                  <a:srgbClr val="0F172A"/>
+                </a:solidFill>
+                <a:latin typeface="Calibri"/>
+              </a:rPr>
+              <a:t>• Complete Documentation Suite: </a:t>
+            </a:r>
+            <a:r>
+              <a:rPr sz="1050" b="0">
+                <a:solidFill>
+                  <a:srgbClr val="1E293B"/>
+                </a:solidFill>
+                <a:latin typeface="Calibri"/>
+              </a:rPr>
+              <a:t>Comprehensive documentation indexed in MD_Files/ (ARCHITECTURE.md, FEATURES.md, MANUAL_TEST_REPORT.md, DEMO_SCRIPT.md, TERRAFORM.md).</a:t>
             </a:r>
           </a:p>
           <a:p>
             <a:pPr>
-              <a:defRPr sz="980" b="0">
-                <a:solidFill>
-                  <a:srgbClr val="0F172A"/>
-                </a:solidFill>
-                <a:latin typeface="Arial"/>
-              </a:defRPr>
+              <a:lnSpc>
+                <a:spcPct val="112000"/>
+              </a:lnSpc>
+              <a:spcAft>
+                <a:spcPts val="800"/>
+              </a:spcAft>
             </a:pPr>
             <a:r>
-              <a:t>• Clean Public Codebase: Hosted on GitHub (https://github.com/ChiragVasava/gramsaarthi-ai) with clean commit history, Dockerfiles, and Terraform IaC.</a:t>
+              <a:rPr sz="1080" b="1">
+                <a:solidFill>
+                  <a:srgbClr val="0F172A"/>
+                </a:solidFill>
+                <a:latin typeface="Calibri"/>
+              </a:rPr>
+              <a:t>• Demonstration Video Ready: </a:t>
             </a:r>
-          </a:p>
-          <a:p>
-            <a:pPr>
-              <a:defRPr sz="980" b="0">
-                <a:solidFill>
-                  <a:srgbClr val="0F172A"/>
-                </a:solidFill>
-                <a:latin typeface="Arial"/>
-              </a:defRPr>
-            </a:pPr>
             <a:r>
-              <a:t>• Demonstration Video Ready: Rehearsed 3-minute video recording script prepared in MD_Files/DEMO_SCRIPT.md covering the complete walkthrough.</a:t>
+              <a:rPr sz="1050" b="0">
+                <a:solidFill>
+                  <a:srgbClr val="1E293B"/>
+                </a:solidFill>
+                <a:latin typeface="Calibri"/>
+              </a:rPr>
+              <a:t>Rehearsed 3-minute video recording script prepared in MD_Files/DEMO_SCRIPT.md covering the complete walkthrough.</a:t>
             </a:r>
           </a:p>
         </p:txBody>

</xml_diff>

<commit_message>
fix: clean slide 1 team name, clean slide 6 header to Additional Details, and remove scratch scripts
</commit_message>
<xml_diff>
--- a/MD_Files/GramSaarthi_AI_Hackathon_Presentation.pptx
+++ b/MD_Files/GramSaarthi_AI_Hackathon_Presentation.pptx
@@ -12384,15 +12384,6 @@
               </a:rPr>
               <a:t>Team Name: </a:t>
             </a:r>
-            <a:r>
-              <a:rPr sz="1450" b="1">
-                <a:solidFill>
-                  <a:srgbClr val="0F172A"/>
-                </a:solidFill>
-                <a:latin typeface="Calibri"/>
-              </a:rPr>
-              <a:t>GramSaarthi AI</a:t>
-            </a:r>
           </a:p>
           <a:p>
             <a:pPr>
@@ -15010,8 +15001,8 @@
         </p:nvSpPr>
         <p:spPr>
           <a:xfrm>
-            <a:off x="341371" y="215255"/>
-            <a:ext cx="8520600" cy="841800"/>
+            <a:off x="594360" y="411480"/>
+            <a:ext cx="7955279" cy="548640"/>
           </a:xfrm>
           <a:prstGeom prst="rect">
             <a:avLst/>
@@ -15039,37 +15030,15 @@
               </a:spcAft>
               <a:buSzPct val="120000"/>
               <a:buNone/>
+              <a:defRPr sz="2600" b="1">
+                <a:solidFill>
+                  <a:srgbClr val="0F172A"/>
+                </a:solidFill>
+                <a:latin typeface="Calibri"/>
+              </a:defRPr>
             </a:pPr>
             <a:r>
-              <a:rPr b="1" lang="en-GB" sz="3000">
-                <a:solidFill>
-                  <a:schemeClr val="dk1"/>
-                </a:solidFill>
-              </a:rPr>
-              <a:t>Additional Details(</a:t>
-            </a:r>
-            <a:r>
-              <a:rPr b="1" lang="en-GB" sz="1800">
-                <a:solidFill>
-                  <a:schemeClr val="dk1"/>
-                </a:solidFill>
-              </a:rPr>
-              <a:t>Kee</a:t>
-            </a:r>
-            <a:r>
-              <a:rPr b="1" lang="en-GB" sz="1800"/>
-              <a:t>p the content limited to</a:t>
-            </a:r>
-            <a:br>
-              <a:rPr b="1" lang="en-GB" sz="1800"/>
-            </a:br>
-            <a:r>
-              <a:rPr b="1" lang="en-GB" sz="1800"/>
-              <a:t>t</a:t>
-            </a:r>
-            <a:r>
-              <a:rPr b="1" lang="en-GB" sz="1800"/>
-              <a:t>his slide only)</a:t>
+              <a:t>Additional Details</a:t>
             </a:r>
             <a:endParaRPr sz="1800"/>
           </a:p>

</xml_diff>